<commit_message>
feat(mcu): scaffold STM32G071 + INA226 firmware
新增 MCU 韌體骨架，對應 meeting_0416 的鋰電池 SOC/SOH 動態阻抗法 MCU 驗證計畫。

- Drivers/INA226：HAL I2C 驅動（CONFIG/CAL/讀值 API）
- App/battery_monitor：取樣排程與樣本快取
- App/soc_soh_calc：動態阻抗法 + 投影法 SOC/SOH 骨架（校正 pending）
- Core 主程式骨架 + 腳位與系統參數巨集
- README + docs/wiring：含 ASCII 接線圖、連線清單、訊號完整性建議
- 同步更新 CLAUDE.md 今日總結與 meeting_0416 簡報
</commit_message>
<xml_diff>
--- a/DOC/會議紀錄/meeting_0416_洪大甲.pptx
+++ b/DOC/會議紀錄/meeting_0416_洪大甲.pptx
@@ -4,6 +4,9 @@
   <p:sldMasterIdLst>
     <p:sldMasterId id="2147483648" r:id="rId1"/>
   </p:sldMasterIdLst>
+  <p:notesMasterIdLst>
+    <p:notesMasterId r:id="rId12"/>
+  </p:notesMasterIdLst>
   <p:sldIdLst>
     <p:sldId id="256" r:id="rId2"/>
     <p:sldId id="257" r:id="rId3"/>
@@ -16,10 +19,7 @@
     <p:sldId id="264" r:id="rId10"/>
     <p:sldId id="265" r:id="rId11"/>
   </p:sldIdLst>
-  <p:notesMasterIdLst>
-    <p:notesMasterId r:id="rId12"/>
-  </p:notesMasterIdLst>
-  <p:sldSz cx="9144000" cy="5143500"/>
+  <p:sldSz cx="9144000" cy="5143500" type="screen16x9"/>
   <p:notesSz cx="5143500" cy="9144000"/>
   <p:defaultTextStyle>
     <a:lvl1pPr marL="0" algn="l" defTabSz="914400" rtl="0" eaLnBrk="1" latinLnBrk="0" hangingPunct="1">
@@ -113,6 +113,11 @@
       </a:defRPr>
     </a:lvl9pPr>
   </p:defaultTextStyle>
+  <p:extLst>
+    <p:ext uri="{EFAFB233-063F-42B5-8137-9DF3F51BA10A}">
+      <p15:sldGuideLst xmlns:p15="http://schemas.microsoft.com/office/powerpoint/2012/main"/>
+    </p:ext>
+  </p:extLst>
 </p:presentation>
 </file>
 
@@ -138,234 +143,10 @@
           <a:chExt cx="0" cy="0"/>
         </a:xfrm>
       </p:grpSpPr>
-      <p:sp>
-        <p:nvSpPr>
-          <p:cNvPr id="2" name="Header Placeholder 1"/>
-          <p:cNvSpPr>
-            <a:spLocks noGrp="1"/>
-          </p:cNvSpPr>
-          <p:nvPr>
-            <p:ph type="hdr" sz="quarter"/>
-          </p:nvPr>
-        </p:nvSpPr>
-        <p:spPr>
-          <a:xfrm>
-            <a:off x="0" y="0"/>
-            <a:ext cx="2971800" cy="458788"/>
-          </a:xfrm>
-          <a:prstGeom prst="rect">
-            <a:avLst/>
-          </a:prstGeom>
-        </p:spPr>
-        <p:txBody>
-          <a:bodyPr vert="horz" lIns="91440" tIns="45720" rIns="91440" bIns="45720" rtlCol="0"/>
-          <a:lstStyle>
-            <a:lvl1pPr algn="l">
-              <a:defRPr sz="1200"/>
-            </a:lvl1pPr>
-          </a:lstStyle>
-          <a:p>
-            <a:endParaRPr lang="en-US"/>
-          </a:p>
-        </p:txBody>
-      </p:sp>
-      <p:sp>
-        <p:nvSpPr>
-          <p:cNvPr id="3" name="Date Placeholder 2"/>
-          <p:cNvSpPr>
-            <a:spLocks noGrp="1"/>
-          </p:cNvSpPr>
-          <p:nvPr>
-            <p:ph type="dt" idx="1"/>
-          </p:nvPr>
-        </p:nvSpPr>
-        <p:spPr>
-          <a:xfrm>
-            <a:off x="3884613" y="0"/>
-            <a:ext cx="2971800" cy="458788"/>
-          </a:xfrm>
-          <a:prstGeom prst="rect">
-            <a:avLst/>
-          </a:prstGeom>
-        </p:spPr>
-        <p:txBody>
-          <a:bodyPr vert="horz" lIns="91440" tIns="45720" rIns="91440" bIns="45720" rtlCol="0"/>
-          <a:lstStyle>
-            <a:lvl1pPr algn="r">
-              <a:defRPr sz="1200"/>
-            </a:lvl1pPr>
-          </a:lstStyle>
-          <a:p>
-            <a:fld id="{5282F153-3F37-0F45-9E97-73ACFA13230C}" type="datetimeFigureOut">
-              <a:rPr lang="en-US"/>
-              <a:t>7/23/19</a:t>
-            </a:fld>
-            <a:endParaRPr lang="en-US"/>
-          </a:p>
-        </p:txBody>
-      </p:sp>
-      <p:sp>
-        <p:nvSpPr>
-          <p:cNvPr id="4" name="Slide Image Placeholder 3"/>
-          <p:cNvSpPr>
-            <a:spLocks noGrp="1" noRot="1" noChangeAspect="1"/>
-          </p:cNvSpPr>
-          <p:nvPr>
-            <p:ph type="sldImg" idx="2"/>
-          </p:nvPr>
-        </p:nvSpPr>
-        <p:spPr>
-          <a:xfrm>
-            <a:off x="685800" y="1143000"/>
-            <a:ext cx="5486400" cy="3086100"/>
-          </a:xfrm>
-          <a:prstGeom prst="rect">
-            <a:avLst/>
-          </a:prstGeom>
-          <a:noFill/>
-          <a:ln w="12700">
-            <a:solidFill>
-              <a:prstClr val="black"/>
-            </a:solidFill>
-          </a:ln>
-        </p:spPr>
-        <p:txBody>
-          <a:bodyPr vert="horz" lIns="91440" tIns="45720" rIns="91440" bIns="45720" rtlCol="0" anchor="ctr"/>
-          <a:lstStyle/>
-          <a:p>
-            <a:endParaRPr lang="en-US"/>
-          </a:p>
-        </p:txBody>
-      </p:sp>
-      <p:sp>
-        <p:nvSpPr>
-          <p:cNvPr id="5" name="Notes Placeholder 4"/>
-          <p:cNvSpPr>
-            <a:spLocks noGrp="1"/>
-          </p:cNvSpPr>
-          <p:nvPr>
-            <p:ph type="body" sz="quarter" idx="3"/>
-          </p:nvPr>
-        </p:nvSpPr>
-        <p:spPr>
-          <a:xfrm>
-            <a:off x="685800" y="4400550"/>
-            <a:ext cx="5486400" cy="3600450"/>
-          </a:xfrm>
-          <a:prstGeom prst="rect">
-            <a:avLst/>
-          </a:prstGeom>
-        </p:spPr>
-        <p:txBody>
-          <a:bodyPr vert="horz" lIns="91440" tIns="45720" rIns="91440" bIns="45720" rtlCol="0"/>
-          <a:lstStyle/>
-          <a:p>
-            <a:pPr lvl="0"/>
-            <a:r>
-              <a:rPr lang="en-US"/>
-              <a:t>Click to edit Master text styles</a:t>
-            </a:r>
-          </a:p>
-          <a:p>
-            <a:pPr lvl="1"/>
-            <a:r>
-              <a:rPr lang="en-US"/>
-              <a:t>Second level</a:t>
-            </a:r>
-          </a:p>
-          <a:p>
-            <a:pPr lvl="2"/>
-            <a:r>
-              <a:rPr lang="en-US"/>
-              <a:t>Third level</a:t>
-            </a:r>
-          </a:p>
-          <a:p>
-            <a:pPr lvl="3"/>
-            <a:r>
-              <a:rPr lang="en-US"/>
-              <a:t>Fourth level</a:t>
-            </a:r>
-          </a:p>
-          <a:p>
-            <a:pPr lvl="4"/>
-            <a:r>
-              <a:rPr lang="en-US"/>
-              <a:t>Fifth level</a:t>
-            </a:r>
-          </a:p>
-        </p:txBody>
-      </p:sp>
-      <p:sp>
-        <p:nvSpPr>
-          <p:cNvPr id="6" name="Footer Placeholder 5"/>
-          <p:cNvSpPr>
-            <a:spLocks noGrp="1"/>
-          </p:cNvSpPr>
-          <p:nvPr>
-            <p:ph type="ftr" sz="quarter" idx="4"/>
-          </p:nvPr>
-        </p:nvSpPr>
-        <p:spPr>
-          <a:xfrm>
-            <a:off x="0" y="8685213"/>
-            <a:ext cx="2971800" cy="458787"/>
-          </a:xfrm>
-          <a:prstGeom prst="rect">
-            <a:avLst/>
-          </a:prstGeom>
-        </p:spPr>
-        <p:txBody>
-          <a:bodyPr vert="horz" lIns="91440" tIns="45720" rIns="91440" bIns="45720" rtlCol="0" anchor="b"/>
-          <a:lstStyle>
-            <a:lvl1pPr algn="l">
-              <a:defRPr sz="1200"/>
-            </a:lvl1pPr>
-          </a:lstStyle>
-          <a:p>
-            <a:endParaRPr lang="en-US"/>
-          </a:p>
-        </p:txBody>
-      </p:sp>
-      <p:sp>
-        <p:nvSpPr>
-          <p:cNvPr id="7" name="Slide Number Placeholder 6"/>
-          <p:cNvSpPr>
-            <a:spLocks noGrp="1"/>
-          </p:cNvSpPr>
-          <p:nvPr>
-            <p:ph type="sldNum" sz="quarter" idx="5"/>
-          </p:nvPr>
-        </p:nvSpPr>
-        <p:spPr>
-          <a:xfrm>
-            <a:off x="3884613" y="8685213"/>
-            <a:ext cx="2971800" cy="458787"/>
-          </a:xfrm>
-          <a:prstGeom prst="rect">
-            <a:avLst/>
-          </a:prstGeom>
-        </p:spPr>
-        <p:txBody>
-          <a:bodyPr vert="horz" lIns="91440" tIns="45720" rIns="91440" bIns="45720" rtlCol="0" anchor="b"/>
-          <a:lstStyle>
-            <a:lvl1pPr algn="r">
-              <a:defRPr sz="1200"/>
-            </a:lvl1pPr>
-          </a:lstStyle>
-          <a:p>
-            <a:fld id="{CE5E9CC1-C706-0F49-92D6-E571CC5EEA8F}" type="slidenum">
-              <a:rPr lang="en-US"/>
-              <a:t>‹#›</a:t>
-            </a:fld>
-            <a:endParaRPr lang="en-US"/>
-          </a:p>
-        </p:txBody>
-      </p:sp>
     </p:spTree>
     <p:extLst>
       <p:ext uri="{BB962C8B-B14F-4D97-AF65-F5344CB8AC3E}">
-        <p14:creationId xmlns:p14="http://schemas.microsoft.com/office/powerpoint/2010/main" val="1024086991"/>
+        <p14:creationId xmlns:p14="http://schemas.microsoft.com/office/powerpoint/2010/main" val="2377279554"/>
       </p:ext>
     </p:extLst>
   </p:cSld>
@@ -509,10 +290,6 @@
           <a:bodyPr/>
           <a:lstStyle/>
           <a:p>
-            <a:r>
-              <a:rPr lang="en-US" dirty="0"/>
-              <a:t/>
-            </a:r>
             <a:endParaRPr lang="en-US" dirty="0"/>
           </a:p>
         </p:txBody>
@@ -597,10 +374,6 @@
           <a:bodyPr/>
           <a:lstStyle/>
           <a:p>
-            <a:r>
-              <a:rPr lang="en-US" dirty="0"/>
-              <a:t/>
-            </a:r>
             <a:endParaRPr lang="en-US" dirty="0"/>
           </a:p>
         </p:txBody>
@@ -685,10 +458,6 @@
           <a:bodyPr/>
           <a:lstStyle/>
           <a:p>
-            <a:r>
-              <a:rPr lang="en-US" dirty="0"/>
-              <a:t/>
-            </a:r>
             <a:endParaRPr lang="en-US" dirty="0"/>
           </a:p>
         </p:txBody>
@@ -773,10 +542,6 @@
           <a:bodyPr/>
           <a:lstStyle/>
           <a:p>
-            <a:r>
-              <a:rPr lang="en-US" dirty="0"/>
-              <a:t/>
-            </a:r>
             <a:endParaRPr lang="en-US" dirty="0"/>
           </a:p>
         </p:txBody>
@@ -861,10 +626,6 @@
           <a:bodyPr/>
           <a:lstStyle/>
           <a:p>
-            <a:r>
-              <a:rPr lang="en-US" dirty="0"/>
-              <a:t/>
-            </a:r>
             <a:endParaRPr lang="en-US" dirty="0"/>
           </a:p>
         </p:txBody>
@@ -949,10 +710,6 @@
           <a:bodyPr/>
           <a:lstStyle/>
           <a:p>
-            <a:r>
-              <a:rPr lang="en-US" dirty="0"/>
-              <a:t/>
-            </a:r>
             <a:endParaRPr lang="en-US" dirty="0"/>
           </a:p>
         </p:txBody>
@@ -1037,10 +794,6 @@
           <a:bodyPr/>
           <a:lstStyle/>
           <a:p>
-            <a:r>
-              <a:rPr lang="en-US" dirty="0"/>
-              <a:t/>
-            </a:r>
             <a:endParaRPr lang="en-US" dirty="0"/>
           </a:p>
         </p:txBody>
@@ -1125,10 +878,6 @@
           <a:bodyPr/>
           <a:lstStyle/>
           <a:p>
-            <a:r>
-              <a:rPr lang="en-US" dirty="0"/>
-              <a:t/>
-            </a:r>
             <a:endParaRPr lang="en-US" dirty="0"/>
           </a:p>
         </p:txBody>
@@ -1213,10 +962,6 @@
           <a:bodyPr/>
           <a:lstStyle/>
           <a:p>
-            <a:r>
-              <a:rPr lang="en-US" dirty="0"/>
-              <a:t/>
-            </a:r>
             <a:endParaRPr lang="en-US" dirty="0"/>
           </a:p>
         </p:txBody>
@@ -1301,10 +1046,6 @@
           <a:bodyPr/>
           <a:lstStyle/>
           <a:p>
-            <a:r>
-              <a:rPr lang="en-US" dirty="0"/>
-              <a:t/>
-            </a:r>
             <a:endParaRPr lang="en-US" dirty="0"/>
           </a:p>
         </p:txBody>
@@ -1378,6 +1119,11 @@
 <file path=ppt/slideMasters/slideMaster1.xml><?xml version="1.0" encoding="utf-8"?>
 <p:sldMaster xmlns:a="http://schemas.openxmlformats.org/drawingml/2006/main" xmlns:r="http://schemas.openxmlformats.org/officeDocument/2006/relationships" xmlns:p="http://schemas.openxmlformats.org/presentationml/2006/main">
   <p:cSld>
+    <p:bg>
+      <p:bgRef idx="1001">
+        <a:schemeClr val="bg1"/>
+      </p:bgRef>
+    </p:bg>
     <p:spTree>
       <p:nvGrpSpPr>
         <p:cNvPr id="1" name=""/>
@@ -1660,6 +1406,7 @@
         <a:solidFill>
           <a:srgbClr val="21295C"/>
         </a:solidFill>
+        <a:effectLst/>
       </p:bgPr>
     </p:bg>
     <p:spTree>
@@ -1717,11 +1464,11 @@
           <a:bodyPr wrap="square" rtlCol="0" anchor="ctr"/>
           <a:lstStyle/>
           <a:p>
-            <a:pPr indent="0" marL="0">
-              <a:buNone/>
-            </a:pPr>
-            <a:r>
-              <a:rPr lang="en-US" sz="4000" b="1" dirty="0">
+            <a:pPr marL="0" indent="0">
+              <a:buNone/>
+            </a:pPr>
+            <a:r>
+              <a:rPr lang="zh-TW" altLang="en-US" sz="4000" b="1" dirty="0">
                 <a:solidFill>
                   <a:srgbClr val="FFFFFF"/>
                 </a:solidFill>
@@ -1729,45 +1476,67 @@
                 <a:ea typeface="Microsoft JhengHei" pitchFamily="34" charset="-122"/>
                 <a:cs typeface="Microsoft JhengHei" pitchFamily="34" charset="-120"/>
               </a:rPr>
-              <a:t>鏨電池 SOC/SOH 估計</a:t>
-            </a:r>
-            <a:endParaRPr lang="en-US" sz="4000" dirty="0"/>
-          </a:p>
-        </p:txBody>
-      </p:sp>
-      <p:sp>
-        <p:nvSpPr>
-          <p:cNvPr id="4" name="Text 2"/>
-          <p:cNvSpPr/>
-          <p:nvPr/>
-        </p:nvSpPr>
-        <p:spPr>
-          <a:xfrm>
-            <a:off x="731520" y="1737360"/>
-            <a:ext cx="7680960" cy="731520"/>
-          </a:xfrm>
-          <a:prstGeom prst="rect">
-            <a:avLst/>
-          </a:prstGeom>
-          <a:noFill/>
-          <a:ln/>
-        </p:spPr>
-        <p:txBody>
-          <a:bodyPr wrap="square" rtlCol="0" anchor="ctr"/>
-          <a:lstStyle/>
-          <a:p>
-            <a:pPr indent="0" marL="0">
-              <a:buNone/>
-            </a:pPr>
-            <a:r>
-              <a:rPr lang="en-US" sz="2800" dirty="0">
-                <a:solidFill>
-                  <a:srgbClr val="CADCFC"/>
+              <a:t>鋰</a:t>
+            </a:r>
+            <a:r>
+              <a:rPr lang="en-US" sz="4000" b="1" dirty="0" err="1">
+                <a:solidFill>
+                  <a:srgbClr val="FFFFFF"/>
                 </a:solidFill>
                 <a:latin typeface="Microsoft JhengHei" pitchFamily="34" charset="0"/>
                 <a:ea typeface="Microsoft JhengHei" pitchFamily="34" charset="-122"/>
                 <a:cs typeface="Microsoft JhengHei" pitchFamily="34" charset="-120"/>
               </a:rPr>
+              <a:t>電池</a:t>
+            </a:r>
+            <a:r>
+              <a:rPr lang="en-US" sz="4000" b="1" dirty="0">
+                <a:solidFill>
+                  <a:srgbClr val="FFFFFF"/>
+                </a:solidFill>
+                <a:latin typeface="Microsoft JhengHei" pitchFamily="34" charset="0"/>
+                <a:ea typeface="Microsoft JhengHei" pitchFamily="34" charset="-122"/>
+                <a:cs typeface="Microsoft JhengHei" pitchFamily="34" charset="-120"/>
+              </a:rPr>
+              <a:t> SOC/SOH 估計</a:t>
+            </a:r>
+            <a:endParaRPr lang="en-US" sz="4000" dirty="0"/>
+          </a:p>
+        </p:txBody>
+      </p:sp>
+      <p:sp>
+        <p:nvSpPr>
+          <p:cNvPr id="4" name="Text 2"/>
+          <p:cNvSpPr/>
+          <p:nvPr/>
+        </p:nvSpPr>
+        <p:spPr>
+          <a:xfrm>
+            <a:off x="731520" y="1737360"/>
+            <a:ext cx="7680960" cy="731520"/>
+          </a:xfrm>
+          <a:prstGeom prst="rect">
+            <a:avLst/>
+          </a:prstGeom>
+          <a:noFill/>
+          <a:ln/>
+        </p:spPr>
+        <p:txBody>
+          <a:bodyPr wrap="square" rtlCol="0" anchor="ctr"/>
+          <a:lstStyle/>
+          <a:p>
+            <a:pPr marL="0" indent="0">
+              <a:buNone/>
+            </a:pPr>
+            <a:r>
+              <a:rPr lang="en-US" sz="2800" dirty="0">
+                <a:solidFill>
+                  <a:srgbClr val="CADCFC"/>
+                </a:solidFill>
+                <a:latin typeface="Microsoft JhengHei" pitchFamily="34" charset="0"/>
+                <a:ea typeface="Microsoft JhengHei" pitchFamily="34" charset="-122"/>
+                <a:cs typeface="Microsoft JhengHei" pitchFamily="34" charset="-120"/>
+              </a:rPr>
               <a:t>動態阻抗法 MCU 驗證計畫</a:t>
             </a:r>
             <a:endParaRPr lang="en-US" sz="2800" dirty="0"/>
@@ -1795,7 +1564,7 @@
           <a:bodyPr wrap="square" rtlCol="0" anchor="ctr"/>
           <a:lstStyle/>
           <a:p>
-            <a:pPr indent="0" marL="0">
+            <a:pPr marL="0" indent="0">
               <a:buNone/>
             </a:pPr>
             <a:r>
@@ -1812,7 +1581,7 @@
             <a:endParaRPr lang="en-US" sz="1300" dirty="0"/>
           </a:p>
           <a:p>
-            <a:pPr indent="0" marL="0">
+            <a:pPr marL="0" indent="0">
               <a:buNone/>
             </a:pPr>
             <a:r>
@@ -1851,7 +1620,7 @@
           <a:bodyPr wrap="square" rtlCol="0" anchor="ctr"/>
           <a:lstStyle/>
           <a:p>
-            <a:pPr algn="r" indent="0" marL="0">
+            <a:pPr marL="0" indent="0" algn="r">
               <a:buNone/>
             </a:pPr>
             <a:r>
@@ -1885,6 +1654,7 @@
         <a:solidFill>
           <a:srgbClr val="21295C"/>
         </a:solidFill>
+        <a:effectLst/>
       </p:bgPr>
     </p:bg>
     <p:spTree>
@@ -1922,7 +1692,7 @@
           <a:bodyPr wrap="square" rtlCol="0" anchor="ctr"/>
           <a:lstStyle/>
           <a:p>
-            <a:pPr algn="ctr" indent="0" marL="0">
+            <a:pPr marL="0" indent="0" algn="ctr">
               <a:buNone/>
             </a:pPr>
             <a:r>
@@ -1961,7 +1731,7 @@
           <a:bodyPr wrap="square" rtlCol="0" anchor="ctr"/>
           <a:lstStyle/>
           <a:p>
-            <a:pPr algn="ctr" indent="0" marL="0">
+            <a:pPr marL="0" indent="0" algn="ctr">
               <a:buNone/>
             </a:pPr>
             <a:r>
@@ -2020,7 +1790,7 @@
           <a:bodyPr wrap="square" rtlCol="0" anchor="ctr"/>
           <a:lstStyle/>
           <a:p>
-            <a:pPr algn="ctr" indent="0" marL="0">
+            <a:pPr marL="0" indent="0" algn="ctr">
               <a:buNone/>
             </a:pPr>
             <a:r>
@@ -2054,6 +1824,7 @@
         <a:solidFill>
           <a:srgbClr val="F4F7FA"/>
         </a:solidFill>
+        <a:effectLst/>
       </p:bgPr>
     </p:bg>
     <p:spTree>
@@ -2091,7 +1862,7 @@
           <a:bodyPr wrap="square" lIns="0" tIns="0" rIns="0" bIns="0" rtlCol="0" anchor="ctr"/>
           <a:lstStyle/>
           <a:p>
-            <a:pPr indent="0" marL="0">
+            <a:pPr marL="0" indent="0">
               <a:buNone/>
             </a:pPr>
             <a:r>
@@ -2148,7 +1919,7 @@
           </a:solidFill>
           <a:ln/>
           <a:effectLst>
-            <a:outerShdw sx="100000" sy="100000" kx="0" ky="0" algn="bl" rotWithShape="0" blurRad="76200" dist="25400" dir="8100000">
+            <a:outerShdw blurRad="76200" dist="25400" dir="8100000" algn="bl" rotWithShape="0">
               <a:srgbClr val="000000">
                 <a:alpha val="12000"/>
               </a:srgbClr>
@@ -2197,7 +1968,7 @@
           <a:bodyPr wrap="square" lIns="0" tIns="0" rIns="0" bIns="0" rtlCol="0" anchor="ctr"/>
           <a:lstStyle/>
           <a:p>
-            <a:pPr indent="0" marL="0">
+            <a:pPr marL="0" indent="0">
               <a:buNone/>
             </a:pPr>
             <a:r>
@@ -2236,7 +2007,7 @@
           <a:bodyPr wrap="square" lIns="0" tIns="0" rIns="0" bIns="0" rtlCol="0" anchor="ctr"/>
           <a:lstStyle/>
           <a:p>
-            <a:pPr indent="0" marL="0">
+            <a:pPr marL="0" indent="0">
               <a:buNone/>
             </a:pPr>
             <a:r>
@@ -2275,7 +2046,7 @@
           <a:bodyPr wrap="square" lIns="0" tIns="0" rIns="0" bIns="0" rtlCol="0" anchor="ctr"/>
           <a:lstStyle/>
           <a:p>
-            <a:pPr indent="0" marL="0">
+            <a:pPr marL="0" indent="0">
               <a:buNone/>
             </a:pPr>
             <a:r>
@@ -2312,7 +2083,7 @@
           </a:solidFill>
           <a:ln/>
           <a:effectLst>
-            <a:outerShdw sx="100000" sy="100000" kx="0" ky="0" algn="bl" rotWithShape="0" blurRad="76200" dist="25400" dir="8100000">
+            <a:outerShdw blurRad="76200" dist="25400" dir="8100000" algn="bl" rotWithShape="0">
               <a:srgbClr val="000000">
                 <a:alpha val="12000"/>
               </a:srgbClr>
@@ -2361,7 +2132,7 @@
           <a:bodyPr wrap="square" lIns="0" tIns="0" rIns="0" bIns="0" rtlCol="0" anchor="ctr"/>
           <a:lstStyle/>
           <a:p>
-            <a:pPr indent="0" marL="0">
+            <a:pPr marL="0" indent="0">
               <a:buNone/>
             </a:pPr>
             <a:r>
@@ -2400,7 +2171,7 @@
           <a:bodyPr wrap="square" lIns="0" tIns="0" rIns="0" bIns="0" rtlCol="0" anchor="ctr"/>
           <a:lstStyle/>
           <a:p>
-            <a:pPr indent="0" marL="0">
+            <a:pPr marL="0" indent="0">
               <a:buNone/>
             </a:pPr>
             <a:r>
@@ -2439,7 +2210,7 @@
           <a:bodyPr wrap="square" lIns="0" tIns="0" rIns="0" bIns="0" rtlCol="0" anchor="ctr"/>
           <a:lstStyle/>
           <a:p>
-            <a:pPr indent="0" marL="0">
+            <a:pPr marL="0" indent="0">
               <a:buNone/>
             </a:pPr>
             <a:r>
@@ -2476,7 +2247,7 @@
           </a:solidFill>
           <a:ln/>
           <a:effectLst>
-            <a:outerShdw sx="100000" sy="100000" kx="0" ky="0" algn="bl" rotWithShape="0" blurRad="76200" dist="25400" dir="8100000">
+            <a:outerShdw blurRad="76200" dist="25400" dir="8100000" algn="bl" rotWithShape="0">
               <a:srgbClr val="000000">
                 <a:alpha val="12000"/>
               </a:srgbClr>
@@ -2525,7 +2296,7 @@
           <a:bodyPr wrap="square" lIns="0" tIns="0" rIns="0" bIns="0" rtlCol="0" anchor="ctr"/>
           <a:lstStyle/>
           <a:p>
-            <a:pPr indent="0" marL="0">
+            <a:pPr marL="0" indent="0">
               <a:buNone/>
             </a:pPr>
             <a:r>
@@ -2564,7 +2335,7 @@
           <a:bodyPr wrap="square" lIns="0" tIns="0" rIns="0" bIns="0" rtlCol="0" anchor="ctr"/>
           <a:lstStyle/>
           <a:p>
-            <a:pPr indent="0" marL="0">
+            <a:pPr marL="0" indent="0">
               <a:buNone/>
             </a:pPr>
             <a:r>
@@ -2603,7 +2374,7 @@
           <a:bodyPr wrap="square" lIns="0" tIns="0" rIns="0" bIns="0" rtlCol="0" anchor="ctr"/>
           <a:lstStyle/>
           <a:p>
-            <a:pPr indent="0" marL="0">
+            <a:pPr marL="0" indent="0">
               <a:buNone/>
             </a:pPr>
             <a:r>
@@ -2640,7 +2411,7 @@
           </a:solidFill>
           <a:ln/>
           <a:effectLst>
-            <a:outerShdw sx="100000" sy="100000" kx="0" ky="0" algn="bl" rotWithShape="0" blurRad="76200" dist="25400" dir="8100000">
+            <a:outerShdw blurRad="76200" dist="25400" dir="8100000" algn="bl" rotWithShape="0">
               <a:srgbClr val="000000">
                 <a:alpha val="12000"/>
               </a:srgbClr>
@@ -2689,7 +2460,7 @@
           <a:bodyPr wrap="square" lIns="0" tIns="0" rIns="0" bIns="0" rtlCol="0" anchor="ctr"/>
           <a:lstStyle/>
           <a:p>
-            <a:pPr indent="0" marL="0">
+            <a:pPr marL="0" indent="0">
               <a:buNone/>
             </a:pPr>
             <a:r>
@@ -2728,7 +2499,7 @@
           <a:bodyPr wrap="square" lIns="0" tIns="0" rIns="0" bIns="0" rtlCol="0" anchor="ctr"/>
           <a:lstStyle/>
           <a:p>
-            <a:pPr indent="0" marL="0">
+            <a:pPr marL="0" indent="0">
               <a:buNone/>
             </a:pPr>
             <a:r>
@@ -2767,7 +2538,7 @@
           <a:bodyPr wrap="square" lIns="0" tIns="0" rIns="0" bIns="0" rtlCol="0" anchor="ctr"/>
           <a:lstStyle/>
           <a:p>
-            <a:pPr indent="0" marL="0">
+            <a:pPr marL="0" indent="0">
               <a:buNone/>
             </a:pPr>
             <a:r>
@@ -2804,7 +2575,7 @@
           </a:solidFill>
           <a:ln/>
           <a:effectLst>
-            <a:outerShdw sx="100000" sy="100000" kx="0" ky="0" algn="bl" rotWithShape="0" blurRad="76200" dist="25400" dir="8100000">
+            <a:outerShdw blurRad="76200" dist="25400" dir="8100000" algn="bl" rotWithShape="0">
               <a:srgbClr val="000000">
                 <a:alpha val="12000"/>
               </a:srgbClr>
@@ -2853,7 +2624,7 @@
           <a:bodyPr wrap="square" lIns="0" tIns="0" rIns="0" bIns="0" rtlCol="0" anchor="ctr"/>
           <a:lstStyle/>
           <a:p>
-            <a:pPr indent="0" marL="0">
+            <a:pPr marL="0" indent="0">
               <a:buNone/>
             </a:pPr>
             <a:r>
@@ -2892,7 +2663,7 @@
           <a:bodyPr wrap="square" lIns="0" tIns="0" rIns="0" bIns="0" rtlCol="0" anchor="ctr"/>
           <a:lstStyle/>
           <a:p>
-            <a:pPr indent="0" marL="0">
+            <a:pPr marL="0" indent="0">
               <a:buNone/>
             </a:pPr>
             <a:r>
@@ -2931,7 +2702,7 @@
           <a:bodyPr wrap="square" lIns="0" tIns="0" rIns="0" bIns="0" rtlCol="0" anchor="ctr"/>
           <a:lstStyle/>
           <a:p>
-            <a:pPr indent="0" marL="0">
+            <a:pPr marL="0" indent="0">
               <a:buNone/>
             </a:pPr>
             <a:r>
@@ -2968,7 +2739,7 @@
           </a:solidFill>
           <a:ln/>
           <a:effectLst>
-            <a:outerShdw sx="100000" sy="100000" kx="0" ky="0" algn="bl" rotWithShape="0" blurRad="76200" dist="25400" dir="8100000">
+            <a:outerShdw blurRad="76200" dist="25400" dir="8100000" algn="bl" rotWithShape="0">
               <a:srgbClr val="000000">
                 <a:alpha val="12000"/>
               </a:srgbClr>
@@ -3017,7 +2788,7 @@
           <a:bodyPr wrap="square" lIns="0" tIns="0" rIns="0" bIns="0" rtlCol="0" anchor="ctr"/>
           <a:lstStyle/>
           <a:p>
-            <a:pPr indent="0" marL="0">
+            <a:pPr marL="0" indent="0">
               <a:buNone/>
             </a:pPr>
             <a:r>
@@ -3056,7 +2827,7 @@
           <a:bodyPr wrap="square" lIns="0" tIns="0" rIns="0" bIns="0" rtlCol="0" anchor="ctr"/>
           <a:lstStyle/>
           <a:p>
-            <a:pPr indent="0" marL="0">
+            <a:pPr marL="0" indent="0">
               <a:buNone/>
             </a:pPr>
             <a:r>
@@ -3095,7 +2866,7 @@
           <a:bodyPr wrap="square" lIns="0" tIns="0" rIns="0" bIns="0" rtlCol="0" anchor="ctr"/>
           <a:lstStyle/>
           <a:p>
-            <a:pPr indent="0" marL="0">
+            <a:pPr marL="0" indent="0">
               <a:buNone/>
             </a:pPr>
             <a:r>
@@ -3129,6 +2900,7 @@
         <a:solidFill>
           <a:srgbClr val="F4F7FA"/>
         </a:solidFill>
+        <a:effectLst/>
       </p:bgPr>
     </p:bg>
     <p:spTree>
@@ -3166,7 +2938,7 @@
           <a:bodyPr wrap="square" lIns="0" tIns="0" rIns="0" bIns="0" rtlCol="0" anchor="ctr"/>
           <a:lstStyle/>
           <a:p>
-            <a:pPr indent="0" marL="0">
+            <a:pPr marL="0" indent="0">
               <a:buNone/>
             </a:pPr>
             <a:r>
@@ -3223,7 +2995,7 @@
           </a:solidFill>
           <a:ln/>
           <a:effectLst>
-            <a:outerShdw sx="100000" sy="100000" kx="0" ky="0" algn="bl" rotWithShape="0" blurRad="76200" dist="25400" dir="8100000">
+            <a:outerShdw blurRad="76200" dist="25400" dir="8100000" algn="bl" rotWithShape="0">
               <a:srgbClr val="000000">
                 <a:alpha val="12000"/>
               </a:srgbClr>
@@ -3272,7 +3044,7 @@
           <a:bodyPr wrap="square" rtlCol="0" anchor="ctr"/>
           <a:lstStyle/>
           <a:p>
-            <a:pPr algn="ctr" indent="0" marL="0">
+            <a:pPr marL="0" indent="0" algn="ctr">
               <a:buNone/>
             </a:pPr>
             <a:r>
@@ -3311,7 +3083,7 @@
           <a:bodyPr wrap="square" rtlCol="0" anchor="t"/>
           <a:lstStyle/>
           <a:p>
-            <a:pPr indent="0" marL="0">
+            <a:pPr marL="0" indent="0">
               <a:buNone/>
             </a:pPr>
             <a:r>
@@ -3328,7 +3100,7 @@
             <a:endParaRPr lang="en-US" sz="1300" dirty="0"/>
           </a:p>
           <a:p>
-            <a:pPr indent="0" marL="0">
+            <a:pPr marL="0" indent="0">
               <a:buNone/>
             </a:pPr>
             <a:r>
@@ -3345,13 +3117,13 @@
             <a:endParaRPr lang="en-US" sz="1300" dirty="0"/>
           </a:p>
           <a:p>
-            <a:pPr indent="0" marL="0">
+            <a:pPr marL="0" indent="0">
               <a:buNone/>
             </a:pPr>
             <a:endParaRPr lang="en-US" sz="1300" dirty="0"/>
           </a:p>
           <a:p>
-            <a:pPr indent="0" marL="0">
+            <a:pPr marL="0" indent="0">
               <a:buNone/>
             </a:pPr>
             <a:r>
@@ -3368,7 +3140,7 @@
             <a:endParaRPr lang="en-US" sz="1300" dirty="0"/>
           </a:p>
           <a:p>
-            <a:pPr indent="0" marL="0">
+            <a:pPr marL="0" indent="0">
               <a:buNone/>
             </a:pPr>
             <a:r>
@@ -3385,13 +3157,13 @@
             <a:endParaRPr lang="en-US" sz="1300" dirty="0"/>
           </a:p>
           <a:p>
-            <a:pPr indent="0" marL="0">
+            <a:pPr marL="0" indent="0">
               <a:buNone/>
             </a:pPr>
             <a:endParaRPr lang="en-US" sz="1300" dirty="0"/>
           </a:p>
           <a:p>
-            <a:pPr indent="0" marL="0">
+            <a:pPr marL="0" indent="0">
               <a:buNone/>
             </a:pPr>
             <a:r>
@@ -3408,7 +3180,7 @@
             <a:endParaRPr lang="en-US" sz="1300" dirty="0"/>
           </a:p>
           <a:p>
-            <a:pPr indent="0" marL="0">
+            <a:pPr marL="0" indent="0">
               <a:buNone/>
             </a:pPr>
             <a:r>
@@ -3425,7 +3197,7 @@
             <a:endParaRPr lang="en-US" sz="1300" dirty="0"/>
           </a:p>
           <a:p>
-            <a:pPr indent="0" marL="0">
+            <a:pPr marL="0" indent="0">
               <a:buNone/>
             </a:pPr>
             <a:r>
@@ -3442,7 +3214,7 @@
             <a:endParaRPr lang="en-US" sz="1300" dirty="0"/>
           </a:p>
           <a:p>
-            <a:pPr indent="0" marL="0">
+            <a:pPr marL="0" indent="0">
               <a:buNone/>
             </a:pPr>
             <a:r>
@@ -3459,13 +3231,13 @@
             <a:endParaRPr lang="en-US" sz="1300" dirty="0"/>
           </a:p>
           <a:p>
-            <a:pPr indent="0" marL="0">
+            <a:pPr marL="0" indent="0">
               <a:buNone/>
             </a:pPr>
             <a:endParaRPr lang="en-US" sz="1300" dirty="0"/>
           </a:p>
           <a:p>
-            <a:pPr indent="0" marL="0">
+            <a:pPr marL="0" indent="0">
               <a:buNone/>
             </a:pPr>
             <a:r>
@@ -3502,7 +3274,7 @@
           </a:solidFill>
           <a:ln/>
           <a:effectLst>
-            <a:outerShdw sx="100000" sy="100000" kx="0" ky="0" algn="bl" rotWithShape="0" blurRad="76200" dist="25400" dir="8100000">
+            <a:outerShdw blurRad="76200" dist="25400" dir="8100000" algn="bl" rotWithShape="0">
               <a:srgbClr val="000000">
                 <a:alpha val="12000"/>
               </a:srgbClr>
@@ -3551,7 +3323,7 @@
           <a:bodyPr wrap="square" rtlCol="0" anchor="ctr"/>
           <a:lstStyle/>
           <a:p>
-            <a:pPr algn="ctr" indent="0" marL="0">
+            <a:pPr marL="0" indent="0" algn="ctr">
               <a:buNone/>
             </a:pPr>
             <a:r>
@@ -3590,7 +3362,7 @@
           <a:bodyPr wrap="square" rtlCol="0" anchor="t"/>
           <a:lstStyle/>
           <a:p>
-            <a:pPr indent="0" marL="0">
+            <a:pPr marL="0" indent="0">
               <a:buNone/>
             </a:pPr>
             <a:r>
@@ -3607,7 +3379,7 @@
             <a:endParaRPr lang="en-US" sz="1300" dirty="0"/>
           </a:p>
           <a:p>
-            <a:pPr indent="0" marL="0">
+            <a:pPr marL="0" indent="0">
               <a:buNone/>
             </a:pPr>
             <a:r>
@@ -3624,7 +3396,7 @@
             <a:endParaRPr lang="en-US" sz="1300" dirty="0"/>
           </a:p>
           <a:p>
-            <a:pPr indent="0" marL="0">
+            <a:pPr marL="0" indent="0">
               <a:buNone/>
             </a:pPr>
             <a:r>
@@ -3641,7 +3413,7 @@
             <a:endParaRPr lang="en-US" sz="1300" dirty="0"/>
           </a:p>
           <a:p>
-            <a:pPr indent="0" marL="0">
+            <a:pPr marL="0" indent="0">
               <a:buNone/>
             </a:pPr>
             <a:r>
@@ -3658,13 +3430,13 @@
             <a:endParaRPr lang="en-US" sz="1300" dirty="0"/>
           </a:p>
           <a:p>
-            <a:pPr indent="0" marL="0">
+            <a:pPr marL="0" indent="0">
               <a:buNone/>
             </a:pPr>
             <a:endParaRPr lang="en-US" sz="1300" dirty="0"/>
           </a:p>
           <a:p>
-            <a:pPr indent="0" marL="0">
+            <a:pPr marL="0" indent="0">
               <a:buNone/>
             </a:pPr>
             <a:r>
@@ -3681,7 +3453,7 @@
             <a:endParaRPr lang="en-US" sz="1300" dirty="0"/>
           </a:p>
           <a:p>
-            <a:pPr indent="0" marL="0">
+            <a:pPr marL="0" indent="0">
               <a:buNone/>
             </a:pPr>
             <a:r>
@@ -3698,7 +3470,7 @@
             <a:endParaRPr lang="en-US" sz="1300" dirty="0"/>
           </a:p>
           <a:p>
-            <a:pPr indent="0" marL="0">
+            <a:pPr marL="0" indent="0">
               <a:buNone/>
             </a:pPr>
             <a:r>
@@ -3715,13 +3487,13 @@
             <a:endParaRPr lang="en-US" sz="1300" dirty="0"/>
           </a:p>
           <a:p>
-            <a:pPr indent="0" marL="0">
+            <a:pPr marL="0" indent="0">
               <a:buNone/>
             </a:pPr>
             <a:endParaRPr lang="en-US" sz="1300" dirty="0"/>
           </a:p>
           <a:p>
-            <a:pPr indent="0" marL="0">
+            <a:pPr marL="0" indent="0">
               <a:buNone/>
             </a:pPr>
             <a:r>
@@ -3738,7 +3510,7 @@
             <a:endParaRPr lang="en-US" sz="1300" dirty="0"/>
           </a:p>
           <a:p>
-            <a:pPr indent="0" marL="0">
+            <a:pPr marL="0" indent="0">
               <a:buNone/>
             </a:pPr>
             <a:r>
@@ -3755,7 +3527,7 @@
             <a:endParaRPr lang="en-US" sz="1300" dirty="0"/>
           </a:p>
           <a:p>
-            <a:pPr indent="0" marL="0">
+            <a:pPr marL="0" indent="0">
               <a:buNone/>
             </a:pPr>
             <a:r>
@@ -3772,7 +3544,7 @@
             <a:endParaRPr lang="en-US" sz="1300" dirty="0"/>
           </a:p>
           <a:p>
-            <a:pPr indent="0" marL="0">
+            <a:pPr marL="0" indent="0">
               <a:buNone/>
             </a:pPr>
             <a:r>
@@ -3806,6 +3578,7 @@
         <a:solidFill>
           <a:srgbClr val="F4F7FA"/>
         </a:solidFill>
+        <a:effectLst/>
       </p:bgPr>
     </p:bg>
     <p:spTree>
@@ -3843,7 +3616,7 @@
           <a:bodyPr wrap="square" lIns="0" tIns="0" rIns="0" bIns="0" rtlCol="0" anchor="ctr"/>
           <a:lstStyle/>
           <a:p>
-            <a:pPr indent="0" marL="0">
+            <a:pPr marL="0" indent="0">
               <a:buNone/>
             </a:pPr>
             <a:r>
@@ -3900,7 +3673,7 @@
           </a:solidFill>
           <a:ln/>
           <a:effectLst>
-            <a:outerShdw sx="100000" sy="100000" kx="0" ky="0" algn="bl" rotWithShape="0" blurRad="76200" dist="25400" dir="8100000">
+            <a:outerShdw blurRad="76200" dist="25400" dir="8100000" algn="bl" rotWithShape="0">
               <a:srgbClr val="000000">
                 <a:alpha val="12000"/>
               </a:srgbClr>
@@ -3949,7 +3722,7 @@
           <a:bodyPr wrap="square" rtlCol="0" anchor="ctr"/>
           <a:lstStyle/>
           <a:p>
-            <a:pPr algn="ctr" indent="0" marL="0">
+            <a:pPr marL="0" indent="0" algn="ctr">
               <a:buNone/>
             </a:pPr>
             <a:r>
@@ -3966,7 +3739,7 @@
             <a:endParaRPr lang="en-US" sz="1300" dirty="0"/>
           </a:p>
           <a:p>
-            <a:pPr algn="ctr" indent="0" marL="0">
+            <a:pPr marL="0" indent="0" algn="ctr">
               <a:buNone/>
             </a:pPr>
             <a:r>
@@ -4005,7 +3778,7 @@
           <a:bodyPr wrap="square" rtlCol="0" anchor="ctr"/>
           <a:lstStyle/>
           <a:p>
-            <a:pPr algn="ctr" indent="0" marL="0">
+            <a:pPr marL="0" indent="0" algn="ctr">
               <a:buNone/>
             </a:pPr>
             <a:r>
@@ -4042,7 +3815,7 @@
           </a:solidFill>
           <a:ln/>
           <a:effectLst>
-            <a:outerShdw sx="100000" sy="100000" kx="0" ky="0" algn="bl" rotWithShape="0" blurRad="76200" dist="25400" dir="8100000">
+            <a:outerShdw blurRad="76200" dist="25400" dir="8100000" algn="bl" rotWithShape="0">
               <a:srgbClr val="000000">
                 <a:alpha val="12000"/>
               </a:srgbClr>
@@ -4091,11 +3864,11 @@
           <a:bodyPr wrap="square" rtlCol="0" anchor="ctr"/>
           <a:lstStyle/>
           <a:p>
-            <a:pPr algn="ctr" indent="0" marL="0">
-              <a:buNone/>
-            </a:pPr>
-            <a:r>
-              <a:rPr lang="en-US" sz="1300" b="1" dirty="0">
+            <a:pPr marL="0" indent="0" algn="ctr">
+              <a:buNone/>
+            </a:pPr>
+            <a:r>
+              <a:rPr lang="zh-TW" altLang="en-US" sz="1300" b="1" dirty="0">
                 <a:solidFill>
                   <a:srgbClr val="1E293B"/>
                 </a:solidFill>
@@ -4103,16 +3876,10 @@
                 <a:ea typeface="Microsoft JhengHei" pitchFamily="34" charset="-122"/>
                 <a:cs typeface="Microsoft JhengHei" pitchFamily="34" charset="-120"/>
               </a:rPr>
-              <a:t>鏨電池模組</a:t>
-            </a:r>
-            <a:endParaRPr lang="en-US" sz="1300" dirty="0"/>
-          </a:p>
-          <a:p>
-            <a:pPr algn="ctr" indent="0" marL="0">
-              <a:buNone/>
-            </a:pPr>
-            <a:r>
-              <a:rPr lang="en-US" sz="1300" b="1" dirty="0">
+              <a:t>鋰</a:t>
+            </a:r>
+            <a:r>
+              <a:rPr lang="en-US" sz="1300" b="1" dirty="0" err="1">
                 <a:solidFill>
                   <a:srgbClr val="1E293B"/>
                 </a:solidFill>
@@ -4120,7 +3887,24 @@
                 <a:ea typeface="Microsoft JhengHei" pitchFamily="34" charset="-122"/>
                 <a:cs typeface="Microsoft JhengHei" pitchFamily="34" charset="-120"/>
               </a:rPr>
-              <a:t>ICR18650</a:t>
+              <a:t>電池</a:t>
+            </a:r>
+            <a:endParaRPr lang="en-US" sz="1300" dirty="0"/>
+          </a:p>
+          <a:p>
+            <a:pPr marL="0" indent="0" algn="ctr">
+              <a:buNone/>
+            </a:pPr>
+            <a:r>
+              <a:rPr lang="en-US" sz="1300" b="1" dirty="0">
+                <a:solidFill>
+                  <a:srgbClr val="1E293B"/>
+                </a:solidFill>
+                <a:latin typeface="Microsoft JhengHei" pitchFamily="34" charset="0"/>
+                <a:ea typeface="Microsoft JhengHei" pitchFamily="34" charset="-122"/>
+                <a:cs typeface="Microsoft JhengHei" pitchFamily="34" charset="-120"/>
+              </a:rPr>
+              <a:t>18650</a:t>
             </a:r>
             <a:endParaRPr lang="en-US" sz="1300" dirty="0"/>
           </a:p>
@@ -4147,7 +3931,7 @@
           <a:bodyPr wrap="square" rtlCol="0" anchor="ctr"/>
           <a:lstStyle/>
           <a:p>
-            <a:pPr algn="ctr" indent="0" marL="0">
+            <a:pPr marL="0" indent="0" algn="ctr">
               <a:buNone/>
             </a:pPr>
             <a:r>
@@ -4184,7 +3968,7 @@
           </a:solidFill>
           <a:ln/>
           <a:effectLst>
-            <a:outerShdw sx="100000" sy="100000" kx="0" ky="0" algn="bl" rotWithShape="0" blurRad="76200" dist="25400" dir="8100000">
+            <a:outerShdw blurRad="76200" dist="25400" dir="8100000" algn="bl" rotWithShape="0">
               <a:srgbClr val="000000">
                 <a:alpha val="12000"/>
               </a:srgbClr>
@@ -4233,7 +4017,7 @@
           <a:bodyPr wrap="square" rtlCol="0" anchor="ctr"/>
           <a:lstStyle/>
           <a:p>
-            <a:pPr algn="ctr" indent="0" marL="0">
+            <a:pPr marL="0" indent="0" algn="ctr">
               <a:buNone/>
             </a:pPr>
             <a:r>
@@ -4250,7 +4034,7 @@
             <a:endParaRPr lang="en-US" sz="1300" dirty="0"/>
           </a:p>
           <a:p>
-            <a:pPr algn="ctr" indent="0" marL="0">
+            <a:pPr marL="0" indent="0" algn="ctr">
               <a:buNone/>
             </a:pPr>
             <a:r>
@@ -4289,7 +4073,7 @@
           <a:bodyPr wrap="square" rtlCol="0" anchor="ctr"/>
           <a:lstStyle/>
           <a:p>
-            <a:pPr algn="ctr" indent="0" marL="0">
+            <a:pPr marL="0" indent="0" algn="ctr">
               <a:buNone/>
             </a:pPr>
             <a:r>
@@ -4326,7 +4110,7 @@
           </a:solidFill>
           <a:ln/>
           <a:effectLst>
-            <a:outerShdw sx="100000" sy="100000" kx="0" ky="0" algn="bl" rotWithShape="0" blurRad="76200" dist="25400" dir="8100000">
+            <a:outerShdw blurRad="76200" dist="25400" dir="8100000" algn="bl" rotWithShape="0">
               <a:srgbClr val="000000">
                 <a:alpha val="12000"/>
               </a:srgbClr>
@@ -4375,7 +4159,7 @@
           <a:bodyPr wrap="square" rtlCol="0" anchor="ctr"/>
           <a:lstStyle/>
           <a:p>
-            <a:pPr algn="ctr" indent="0" marL="0">
+            <a:pPr marL="0" indent="0" algn="ctr">
               <a:buNone/>
             </a:pPr>
             <a:r>
@@ -4392,7 +4176,7 @@
             <a:endParaRPr lang="en-US" sz="1300" dirty="0"/>
           </a:p>
           <a:p>
-            <a:pPr algn="ctr" indent="0" marL="0">
+            <a:pPr marL="0" indent="0" algn="ctr">
               <a:buNone/>
             </a:pPr>
             <a:r>
@@ -4431,7 +4215,7 @@
           <a:bodyPr wrap="square" rtlCol="0" anchor="ctr"/>
           <a:lstStyle/>
           <a:p>
-            <a:pPr algn="ctr" indent="0" marL="0">
+            <a:pPr marL="0" indent="0" algn="ctr">
               <a:buNone/>
             </a:pPr>
             <a:r>
@@ -4468,7 +4252,7 @@
           </a:solidFill>
           <a:ln/>
           <a:effectLst>
-            <a:outerShdw sx="100000" sy="100000" kx="0" ky="0" algn="bl" rotWithShape="0" blurRad="76200" dist="25400" dir="8100000">
+            <a:outerShdw blurRad="76200" dist="25400" dir="8100000" algn="bl" rotWithShape="0">
               <a:srgbClr val="000000">
                 <a:alpha val="12000"/>
               </a:srgbClr>
@@ -4517,7 +4301,7 @@
           <a:bodyPr wrap="square" rtlCol="0" anchor="ctr"/>
           <a:lstStyle/>
           <a:p>
-            <a:pPr algn="ctr" indent="0" marL="0">
+            <a:pPr marL="0" indent="0" algn="ctr">
               <a:buNone/>
             </a:pPr>
             <a:r>
@@ -4534,7 +4318,7 @@
             <a:endParaRPr lang="en-US" sz="1300" dirty="0"/>
           </a:p>
           <a:p>
-            <a:pPr algn="ctr" indent="0" marL="0">
+            <a:pPr marL="0" indent="0" algn="ctr">
               <a:buNone/>
             </a:pPr>
             <a:r>
@@ -4573,7 +4357,7 @@
           <a:bodyPr wrap="square" rtlCol="0" anchor="ctr"/>
           <a:lstStyle/>
           <a:p>
-            <a:pPr algn="ctr" indent="0" marL="0">
+            <a:pPr marL="0" indent="0" algn="ctr">
               <a:buNone/>
             </a:pPr>
             <a:r>
@@ -4704,7 +4488,7 @@
           <a:bodyPr wrap="square" rtlCol="0" anchor="ctr"/>
           <a:lstStyle/>
           <a:p>
-            <a:pPr algn="ctr" indent="0" marL="0">
+            <a:pPr marL="0" indent="0" algn="ctr">
               <a:buNone/>
             </a:pPr>
             <a:r>
@@ -4738,6 +4522,7 @@
         <a:solidFill>
           <a:srgbClr val="F4F7FA"/>
         </a:solidFill>
+        <a:effectLst/>
       </p:bgPr>
     </p:bg>
     <p:spTree>
@@ -4775,7 +4560,7 @@
           <a:bodyPr wrap="square" lIns="0" tIns="0" rIns="0" bIns="0" rtlCol="0" anchor="ctr"/>
           <a:lstStyle/>
           <a:p>
-            <a:pPr indent="0" marL="0">
+            <a:pPr marL="0" indent="0">
               <a:buNone/>
             </a:pPr>
             <a:r>
@@ -4822,24 +4607,48 @@
           <p:nvPr>
             <p:extLst>
               <p:ext uri="{D42A27DB-BD31-4B8C-83A1-F6EECF244321}">
-                <p14:modId xmlns:p14="http://schemas.microsoft.com/office/powerpoint/2010/main" val="1579011935"/>
+                <p14:modId xmlns:p14="http://schemas.microsoft.com/office/powerpoint/2010/main" val="1310581791"/>
               </p:ext>
             </p:extLst>
           </p:nvPr>
         </p:nvGraphicFramePr>
         <p:xfrm>
           <a:off x="640080" y="1097280"/>
-          <a:ext cx="7863840" cy="914400"/>
+          <a:ext cx="7863840" cy="2423160"/>
         </p:xfrm>
         <a:graphic>
           <a:graphicData uri="http://schemas.openxmlformats.org/drawingml/2006/table">
             <a:tbl>
               <a:tblPr/>
               <a:tblGrid>
-                <a:gridCol w="1371600"/>
-                <a:gridCol w="1828800"/>
-                <a:gridCol w="1828800"/>
-                <a:gridCol w="2834640"/>
+                <a:gridCol w="1371600">
+                  <a:extLst>
+                    <a:ext uri="{9D8B030D-6E8A-4147-A177-3AD203B41FA5}">
+                      <a16:colId xmlns:a16="http://schemas.microsoft.com/office/drawing/2014/main" val="20000"/>
+                    </a:ext>
+                  </a:extLst>
+                </a:gridCol>
+                <a:gridCol w="1828800">
+                  <a:extLst>
+                    <a:ext uri="{9D8B030D-6E8A-4147-A177-3AD203B41FA5}">
+                      <a16:colId xmlns:a16="http://schemas.microsoft.com/office/drawing/2014/main" val="20001"/>
+                    </a:ext>
+                  </a:extLst>
+                </a:gridCol>
+                <a:gridCol w="1828800">
+                  <a:extLst>
+                    <a:ext uri="{9D8B030D-6E8A-4147-A177-3AD203B41FA5}">
+                      <a16:colId xmlns:a16="http://schemas.microsoft.com/office/drawing/2014/main" val="20002"/>
+                    </a:ext>
+                  </a:extLst>
+                </a:gridCol>
+                <a:gridCol w="2834640">
+                  <a:extLst>
+                    <a:ext uri="{9D8B030D-6E8A-4147-A177-3AD203B41FA5}">
+                      <a16:colId xmlns:a16="http://schemas.microsoft.com/office/drawing/2014/main" val="20003"/>
+                    </a:ext>
+                  </a:extLst>
+                </a:gridCol>
               </a:tblGrid>
               <a:tr h="365760">
                 <a:tc>
@@ -4847,7 +4656,7 @@
                     <a:bodyPr/>
                     <a:lstStyle/>
                     <a:p>
-                      <a:pPr indent="0" marL="0">
+                      <a:pPr marL="0" indent="0">
                         <a:buNone/>
                       </a:pPr>
                       <a:r>
@@ -4868,7 +4677,7 @@
                       </a:endParaRPr>
                     </a:p>
                   </a:txBody>
-                  <a:tcPr marL="91440" marR="91440" marT="45720" marB="45720">
+                  <a:tcPr>
                     <a:lnL w="6350" cap="flat" cmpd="sng" algn="ctr">
                       <a:solidFill>
                         <a:srgbClr val="D0D5DD"/>
@@ -4915,7 +4724,7 @@
                     <a:bodyPr/>
                     <a:lstStyle/>
                     <a:p>
-                      <a:pPr indent="0" marL="0">
+                      <a:pPr marL="0" indent="0">
                         <a:buNone/>
                       </a:pPr>
                       <a:r>
@@ -4936,7 +4745,7 @@
                       </a:endParaRPr>
                     </a:p>
                   </a:txBody>
-                  <a:tcPr marL="91440" marR="91440" marT="45720" marB="45720">
+                  <a:tcPr>
                     <a:lnL w="6350" cap="flat" cmpd="sng" algn="ctr">
                       <a:solidFill>
                         <a:srgbClr val="D0D5DD"/>
@@ -4983,7 +4792,7 @@
                     <a:bodyPr/>
                     <a:lstStyle/>
                     <a:p>
-                      <a:pPr indent="0" marL="0">
+                      <a:pPr marL="0" indent="0">
                         <a:buNone/>
                       </a:pPr>
                       <a:r>
@@ -5004,7 +4813,7 @@
                       </a:endParaRPr>
                     </a:p>
                   </a:txBody>
-                  <a:tcPr marL="91440" marR="91440" marT="45720" marB="45720">
+                  <a:tcPr>
                     <a:lnL w="6350" cap="flat" cmpd="sng" algn="ctr">
                       <a:solidFill>
                         <a:srgbClr val="D0D5DD"/>
@@ -5051,7 +4860,7 @@
                     <a:bodyPr/>
                     <a:lstStyle/>
                     <a:p>
-                      <a:pPr indent="0" marL="0">
+                      <a:pPr marL="0" indent="0">
                         <a:buNone/>
                       </a:pPr>
                       <a:r>
@@ -5072,7 +4881,7 @@
                       </a:endParaRPr>
                     </a:p>
                   </a:txBody>
-                  <a:tcPr marL="91440" marR="91440" marT="45720" marB="45720">
+                  <a:tcPr>
                     <a:lnL w="6350" cap="flat" cmpd="sng" algn="ctr">
                       <a:solidFill>
                         <a:srgbClr val="D0D5DD"/>
@@ -5114,6 +4923,11 @@
                     </a:solidFill>
                   </a:tcPr>
                 </a:tc>
+                <a:extLst>
+                  <a:ext uri="{0D108BD9-81ED-4DB2-BD59-A6C34878D82A}">
+                    <a16:rowId xmlns:a16="http://schemas.microsoft.com/office/drawing/2014/main" val="10000"/>
+                  </a:ext>
+                </a:extLst>
               </a:tr>
               <a:tr h="411480">
                 <a:tc>
@@ -5121,7 +4935,7 @@
                     <a:bodyPr/>
                     <a:lstStyle/>
                     <a:p>
-                      <a:pPr indent="0" marL="0">
+                      <a:pPr marL="0" indent="0">
                         <a:buNone/>
                       </a:pPr>
                       <a:r>
@@ -5142,7 +4956,7 @@
                       </a:endParaRPr>
                     </a:p>
                   </a:txBody>
-                  <a:tcPr marL="91440" marR="91440" marT="45720" marB="45720">
+                  <a:tcPr>
                     <a:lnL w="6350" cap="flat" cmpd="sng" algn="ctr">
                       <a:solidFill>
                         <a:srgbClr val="D0D5DD"/>
@@ -5186,7 +5000,7 @@
                     <a:bodyPr/>
                     <a:lstStyle/>
                     <a:p>
-                      <a:pPr indent="0" marL="0">
+                      <a:pPr marL="0" indent="0">
                         <a:buNone/>
                       </a:pPr>
                       <a:r>
@@ -5207,7 +5021,7 @@
                       </a:endParaRPr>
                     </a:p>
                   </a:txBody>
-                  <a:tcPr marL="91440" marR="91440" marT="45720" marB="45720">
+                  <a:tcPr>
                     <a:lnL w="6350" cap="flat" cmpd="sng" algn="ctr">
                       <a:solidFill>
                         <a:srgbClr val="D0D5DD"/>
@@ -5251,7 +5065,7 @@
                     <a:bodyPr/>
                     <a:lstStyle/>
                     <a:p>
-                      <a:pPr indent="0" marL="0">
+                      <a:pPr marL="0" indent="0">
                         <a:buNone/>
                       </a:pPr>
                       <a:r>
@@ -5272,7 +5086,7 @@
                       </a:endParaRPr>
                     </a:p>
                   </a:txBody>
-                  <a:tcPr marL="91440" marR="91440" marT="45720" marB="45720">
+                  <a:tcPr>
                     <a:lnL w="6350" cap="flat" cmpd="sng" algn="ctr">
                       <a:solidFill>
                         <a:srgbClr val="D0D5DD"/>
@@ -5316,7 +5130,7 @@
                     <a:bodyPr/>
                     <a:lstStyle/>
                     <a:p>
-                      <a:pPr indent="0" marL="0">
+                      <a:pPr marL="0" indent="0">
                         <a:buNone/>
                       </a:pPr>
                       <a:r>
@@ -5337,7 +5151,7 @@
                       </a:endParaRPr>
                     </a:p>
                   </a:txBody>
-                  <a:tcPr marL="91440" marR="91440" marT="45720" marB="45720">
+                  <a:tcPr>
                     <a:lnL w="6350" cap="flat" cmpd="sng" algn="ctr">
                       <a:solidFill>
                         <a:srgbClr val="D0D5DD"/>
@@ -5376,6 +5190,11 @@
                     </a:lnB>
                   </a:tcPr>
                 </a:tc>
+                <a:extLst>
+                  <a:ext uri="{0D108BD9-81ED-4DB2-BD59-A6C34878D82A}">
+                    <a16:rowId xmlns:a16="http://schemas.microsoft.com/office/drawing/2014/main" val="10001"/>
+                  </a:ext>
+                </a:extLst>
               </a:tr>
               <a:tr h="411480">
                 <a:tc>
@@ -5383,7 +5202,7 @@
                     <a:bodyPr/>
                     <a:lstStyle/>
                     <a:p>
-                      <a:pPr indent="0" marL="0">
+                      <a:pPr marL="0" indent="0">
                         <a:buNone/>
                       </a:pPr>
                       <a:r>
@@ -5404,7 +5223,7 @@
                       </a:endParaRPr>
                     </a:p>
                   </a:txBody>
-                  <a:tcPr marL="91440" marR="91440" marT="45720" marB="45720">
+                  <a:tcPr>
                     <a:lnL w="6350" cap="flat" cmpd="sng" algn="ctr">
                       <a:solidFill>
                         <a:srgbClr val="D0D5DD"/>
@@ -5448,7 +5267,7 @@
                     <a:bodyPr/>
                     <a:lstStyle/>
                     <a:p>
-                      <a:pPr indent="0" marL="0">
+                      <a:pPr marL="0" indent="0">
                         <a:buNone/>
                       </a:pPr>
                       <a:r>
@@ -5469,7 +5288,7 @@
                       </a:endParaRPr>
                     </a:p>
                   </a:txBody>
-                  <a:tcPr marL="91440" marR="91440" marT="45720" marB="45720">
+                  <a:tcPr>
                     <a:lnL w="6350" cap="flat" cmpd="sng" algn="ctr">
                       <a:solidFill>
                         <a:srgbClr val="D0D5DD"/>
@@ -5513,7 +5332,7 @@
                     <a:bodyPr/>
                     <a:lstStyle/>
                     <a:p>
-                      <a:pPr indent="0" marL="0">
+                      <a:pPr marL="0" indent="0">
                         <a:buNone/>
                       </a:pPr>
                       <a:r>
@@ -5534,7 +5353,7 @@
                       </a:endParaRPr>
                     </a:p>
                   </a:txBody>
-                  <a:tcPr marL="91440" marR="91440" marT="45720" marB="45720">
+                  <a:tcPr>
                     <a:lnL w="6350" cap="flat" cmpd="sng" algn="ctr">
                       <a:solidFill>
                         <a:srgbClr val="D0D5DD"/>
@@ -5578,7 +5397,7 @@
                     <a:bodyPr/>
                     <a:lstStyle/>
                     <a:p>
-                      <a:pPr indent="0" marL="0">
+                      <a:pPr marL="0" indent="0">
                         <a:buNone/>
                       </a:pPr>
                       <a:r>
@@ -5599,7 +5418,7 @@
                       </a:endParaRPr>
                     </a:p>
                   </a:txBody>
-                  <a:tcPr marL="91440" marR="91440" marT="45720" marB="45720">
+                  <a:tcPr>
                     <a:lnL w="6350" cap="flat" cmpd="sng" algn="ctr">
                       <a:solidFill>
                         <a:srgbClr val="D0D5DD"/>
@@ -5638,6 +5457,11 @@
                     </a:lnB>
                   </a:tcPr>
                 </a:tc>
+                <a:extLst>
+                  <a:ext uri="{0D108BD9-81ED-4DB2-BD59-A6C34878D82A}">
+                    <a16:rowId xmlns:a16="http://schemas.microsoft.com/office/drawing/2014/main" val="10002"/>
+                  </a:ext>
+                </a:extLst>
               </a:tr>
               <a:tr h="411480">
                 <a:tc>
@@ -5645,7 +5469,7 @@
                     <a:bodyPr/>
                     <a:lstStyle/>
                     <a:p>
-                      <a:pPr indent="0" marL="0">
+                      <a:pPr marL="0" indent="0">
                         <a:buNone/>
                       </a:pPr>
                       <a:r>
@@ -5666,7 +5490,7 @@
                       </a:endParaRPr>
                     </a:p>
                   </a:txBody>
-                  <a:tcPr marL="91440" marR="91440" marT="45720" marB="45720">
+                  <a:tcPr>
                     <a:lnL w="6350" cap="flat" cmpd="sng" algn="ctr">
                       <a:solidFill>
                         <a:srgbClr val="D0D5DD"/>
@@ -5710,7 +5534,7 @@
                     <a:bodyPr/>
                     <a:lstStyle/>
                     <a:p>
-                      <a:pPr indent="0" marL="0">
+                      <a:pPr marL="0" indent="0">
                         <a:buNone/>
                       </a:pPr>
                       <a:r>
@@ -5731,7 +5555,7 @@
                       </a:endParaRPr>
                     </a:p>
                   </a:txBody>
-                  <a:tcPr marL="91440" marR="91440" marT="45720" marB="45720">
+                  <a:tcPr>
                     <a:lnL w="6350" cap="flat" cmpd="sng" algn="ctr">
                       <a:solidFill>
                         <a:srgbClr val="D0D5DD"/>
@@ -5775,7 +5599,7 @@
                     <a:bodyPr/>
                     <a:lstStyle/>
                     <a:p>
-                      <a:pPr indent="0" marL="0">
+                      <a:pPr marL="0" indent="0">
                         <a:buNone/>
                       </a:pPr>
                       <a:r>
@@ -5796,7 +5620,7 @@
                       </a:endParaRPr>
                     </a:p>
                   </a:txBody>
-                  <a:tcPr marL="91440" marR="91440" marT="45720" marB="45720">
+                  <a:tcPr>
                     <a:lnL w="6350" cap="flat" cmpd="sng" algn="ctr">
                       <a:solidFill>
                         <a:srgbClr val="D0D5DD"/>
@@ -5840,7 +5664,7 @@
                     <a:bodyPr/>
                     <a:lstStyle/>
                     <a:p>
-                      <a:pPr indent="0" marL="0">
+                      <a:pPr marL="0" indent="0">
                         <a:buNone/>
                       </a:pPr>
                       <a:r>
@@ -5861,7 +5685,7 @@
                       </a:endParaRPr>
                     </a:p>
                   </a:txBody>
-                  <a:tcPr marL="91440" marR="91440" marT="45720" marB="45720">
+                  <a:tcPr>
                     <a:lnL w="6350" cap="flat" cmpd="sng" algn="ctr">
                       <a:solidFill>
                         <a:srgbClr val="D0D5DD"/>
@@ -5900,6 +5724,11 @@
                     </a:lnB>
                   </a:tcPr>
                 </a:tc>
+                <a:extLst>
+                  <a:ext uri="{0D108BD9-81ED-4DB2-BD59-A6C34878D82A}">
+                    <a16:rowId xmlns:a16="http://schemas.microsoft.com/office/drawing/2014/main" val="10003"/>
+                  </a:ext>
+                </a:extLst>
               </a:tr>
               <a:tr h="411480">
                 <a:tc>
@@ -5907,7 +5736,7 @@
                     <a:bodyPr/>
                     <a:lstStyle/>
                     <a:p>
-                      <a:pPr indent="0" marL="0">
+                      <a:pPr marL="0" indent="0">
                         <a:buNone/>
                       </a:pPr>
                       <a:r>
@@ -5928,7 +5757,7 @@
                       </a:endParaRPr>
                     </a:p>
                   </a:txBody>
-                  <a:tcPr marL="91440" marR="91440" marT="45720" marB="45720">
+                  <a:tcPr>
                     <a:lnL w="6350" cap="flat" cmpd="sng" algn="ctr">
                       <a:solidFill>
                         <a:srgbClr val="D0D5DD"/>
@@ -5972,7 +5801,7 @@
                     <a:bodyPr/>
                     <a:lstStyle/>
                     <a:p>
-                      <a:pPr indent="0" marL="0">
+                      <a:pPr marL="0" indent="0">
                         <a:buNone/>
                       </a:pPr>
                       <a:r>
@@ -5993,7 +5822,7 @@
                       </a:endParaRPr>
                     </a:p>
                   </a:txBody>
-                  <a:tcPr marL="91440" marR="91440" marT="45720" marB="45720">
+                  <a:tcPr>
                     <a:lnL w="6350" cap="flat" cmpd="sng" algn="ctr">
                       <a:solidFill>
                         <a:srgbClr val="D0D5DD"/>
@@ -6037,7 +5866,7 @@
                     <a:bodyPr/>
                     <a:lstStyle/>
                     <a:p>
-                      <a:pPr indent="0" marL="0">
+                      <a:pPr marL="0" indent="0">
                         <a:buNone/>
                       </a:pPr>
                       <a:r>
@@ -6058,7 +5887,7 @@
                       </a:endParaRPr>
                     </a:p>
                   </a:txBody>
-                  <a:tcPr marL="91440" marR="91440" marT="45720" marB="45720">
+                  <a:tcPr>
                     <a:lnL w="6350" cap="flat" cmpd="sng" algn="ctr">
                       <a:solidFill>
                         <a:srgbClr val="D0D5DD"/>
@@ -6102,7 +5931,7 @@
                     <a:bodyPr/>
                     <a:lstStyle/>
                     <a:p>
-                      <a:pPr indent="0" marL="0">
+                      <a:pPr marL="0" indent="0">
                         <a:buNone/>
                       </a:pPr>
                       <a:r>
@@ -6123,7 +5952,7 @@
                       </a:endParaRPr>
                     </a:p>
                   </a:txBody>
-                  <a:tcPr marL="91440" marR="91440" marT="45720" marB="45720">
+                  <a:tcPr>
                     <a:lnL w="6350" cap="flat" cmpd="sng" algn="ctr">
                       <a:solidFill>
                         <a:srgbClr val="D0D5DD"/>
@@ -6162,6 +5991,11 @@
                     </a:lnB>
                   </a:tcPr>
                 </a:tc>
+                <a:extLst>
+                  <a:ext uri="{0D108BD9-81ED-4DB2-BD59-A6C34878D82A}">
+                    <a16:rowId xmlns:a16="http://schemas.microsoft.com/office/drawing/2014/main" val="10004"/>
+                  </a:ext>
+                </a:extLst>
               </a:tr>
               <a:tr h="411480">
                 <a:tc>
@@ -6169,7 +6003,7 @@
                     <a:bodyPr/>
                     <a:lstStyle/>
                     <a:p>
-                      <a:pPr indent="0" marL="0">
+                      <a:pPr marL="0" indent="0">
                         <a:buNone/>
                       </a:pPr>
                       <a:r>
@@ -6190,7 +6024,7 @@
                       </a:endParaRPr>
                     </a:p>
                   </a:txBody>
-                  <a:tcPr marL="91440" marR="91440" marT="45720" marB="45720">
+                  <a:tcPr>
                     <a:lnL w="6350" cap="flat" cmpd="sng" algn="ctr">
                       <a:solidFill>
                         <a:srgbClr val="D0D5DD"/>
@@ -6234,7 +6068,7 @@
                     <a:bodyPr/>
                     <a:lstStyle/>
                     <a:p>
-                      <a:pPr indent="0" marL="0">
+                      <a:pPr marL="0" indent="0">
                         <a:buNone/>
                       </a:pPr>
                       <a:r>
@@ -6246,7 +6080,7 @@
                           <a:ea typeface="Calibri" pitchFamily="34" charset="-122"/>
                           <a:cs typeface="Calibri" pitchFamily="34" charset="-120"/>
                         </a:rPr>
-                        <a:t>ICR18650-22P</a:t>
+                        <a:t>18650</a:t>
                       </a:r>
                       <a:endParaRPr lang="en-US" sz="1100" dirty="0">
                         <a:latin typeface="Calibri" charset="0"/>
@@ -6255,7 +6089,7 @@
                       </a:endParaRPr>
                     </a:p>
                   </a:txBody>
-                  <a:tcPr marL="91440" marR="91440" marT="45720" marB="45720">
+                  <a:tcPr>
                     <a:lnL w="6350" cap="flat" cmpd="sng" algn="ctr">
                       <a:solidFill>
                         <a:srgbClr val="D0D5DD"/>
@@ -6299,7 +6133,7 @@
                     <a:bodyPr/>
                     <a:lstStyle/>
                     <a:p>
-                      <a:pPr indent="0" marL="0">
+                      <a:pPr marL="0" indent="0">
                         <a:buNone/>
                       </a:pPr>
                       <a:r>
@@ -6320,7 +6154,7 @@
                       </a:endParaRPr>
                     </a:p>
                   </a:txBody>
-                  <a:tcPr marL="91440" marR="91440" marT="45720" marB="45720">
+                  <a:tcPr>
                     <a:lnL w="6350" cap="flat" cmpd="sng" algn="ctr">
                       <a:solidFill>
                         <a:srgbClr val="D0D5DD"/>
@@ -6364,7 +6198,7 @@
                     <a:bodyPr/>
                     <a:lstStyle/>
                     <a:p>
-                      <a:pPr indent="0" marL="0">
+                      <a:pPr marL="0" indent="0">
                         <a:buNone/>
                       </a:pPr>
                       <a:r>
@@ -6385,7 +6219,7 @@
                       </a:endParaRPr>
                     </a:p>
                   </a:txBody>
-                  <a:tcPr marL="91440" marR="91440" marT="45720" marB="45720">
+                  <a:tcPr>
                     <a:lnL w="6350" cap="flat" cmpd="sng" algn="ctr">
                       <a:solidFill>
                         <a:srgbClr val="D0D5DD"/>
@@ -6424,6 +6258,11 @@
                     </a:lnB>
                   </a:tcPr>
                 </a:tc>
+                <a:extLst>
+                  <a:ext uri="{0D108BD9-81ED-4DB2-BD59-A6C34878D82A}">
+                    <a16:rowId xmlns:a16="http://schemas.microsoft.com/office/drawing/2014/main" val="10005"/>
+                  </a:ext>
+                </a:extLst>
               </a:tr>
             </a:tbl>
           </a:graphicData>
@@ -6448,7 +6287,7 @@
           </a:solidFill>
           <a:ln/>
           <a:effectLst>
-            <a:outerShdw sx="100000" sy="100000" kx="0" ky="0" algn="bl" rotWithShape="0" blurRad="76200" dist="25400" dir="8100000">
+            <a:outerShdw blurRad="76200" dist="25400" dir="8100000" algn="bl" rotWithShape="0">
               <a:srgbClr val="000000">
                 <a:alpha val="12000"/>
               </a:srgbClr>
@@ -6458,7 +6297,7 @@
       </p:sp>
       <p:sp>
         <p:nvSpPr>
-          <p:cNvPr id="6" name="Shape 3"/>
+          <p:cNvPr id="4" name="Shape 3"/>
           <p:cNvSpPr/>
           <p:nvPr/>
         </p:nvSpPr>
@@ -6497,7 +6336,7 @@
           <a:bodyPr wrap="square" lIns="0" tIns="0" rIns="0" bIns="0" rtlCol="0" anchor="ctr"/>
           <a:lstStyle/>
           <a:p>
-            <a:pPr indent="0" marL="0">
+            <a:pPr marL="0" indent="0">
               <a:buNone/>
             </a:pPr>
             <a:r>
@@ -6536,7 +6375,7 @@
           <a:bodyPr wrap="square" lIns="0" tIns="0" rIns="0" bIns="0" rtlCol="0" anchor="ctr"/>
           <a:lstStyle/>
           <a:p>
-            <a:pPr indent="0" marL="0">
+            <a:pPr marL="0" indent="0">
               <a:buNone/>
             </a:pPr>
             <a:r>
@@ -6553,7 +6392,7 @@
             <a:endParaRPr lang="en-US" sz="1100" dirty="0"/>
           </a:p>
           <a:p>
-            <a:pPr indent="0" marL="0">
+            <a:pPr marL="0" indent="0">
               <a:buNone/>
             </a:pPr>
             <a:r>
@@ -6570,7 +6409,7 @@
             <a:endParaRPr lang="en-US" sz="1100" dirty="0"/>
           </a:p>
           <a:p>
-            <a:pPr indent="0" marL="0">
+            <a:pPr marL="0" indent="0">
               <a:buNone/>
             </a:pPr>
             <a:r>
@@ -6604,6 +6443,7 @@
         <a:solidFill>
           <a:srgbClr val="F4F7FA"/>
         </a:solidFill>
+        <a:effectLst/>
       </p:bgPr>
     </p:bg>
     <p:spTree>
@@ -6641,7 +6481,7 @@
           <a:bodyPr wrap="square" lIns="0" tIns="0" rIns="0" bIns="0" rtlCol="0" anchor="ctr"/>
           <a:lstStyle/>
           <a:p>
-            <a:pPr indent="0" marL="0">
+            <a:pPr marL="0" indent="0">
               <a:buNone/>
             </a:pPr>
             <a:r>
@@ -6698,7 +6538,7 @@
           </a:solidFill>
           <a:ln/>
           <a:effectLst>
-            <a:outerShdw sx="100000" sy="100000" kx="0" ky="0" algn="bl" rotWithShape="0" blurRad="76200" dist="25400" dir="8100000">
+            <a:outerShdw blurRad="76200" dist="25400" dir="8100000" algn="bl" rotWithShape="0">
               <a:srgbClr val="000000">
                 <a:alpha val="12000"/>
               </a:srgbClr>
@@ -6747,7 +6587,7 @@
           <a:bodyPr wrap="square" rtlCol="0" anchor="ctr"/>
           <a:lstStyle/>
           <a:p>
-            <a:pPr algn="ctr" indent="0" marL="0">
+            <a:pPr marL="0" indent="0" algn="ctr">
               <a:buNone/>
             </a:pPr>
             <a:r>
@@ -6786,7 +6626,7 @@
           <a:bodyPr wrap="square" rtlCol="0" anchor="t"/>
           <a:lstStyle/>
           <a:p>
-            <a:pPr indent="0" marL="0">
+            <a:pPr marL="0" indent="0">
               <a:buNone/>
             </a:pPr>
             <a:r>
@@ -6803,7 +6643,7 @@
             <a:endParaRPr lang="en-US" sz="1100" dirty="0"/>
           </a:p>
           <a:p>
-            <a:pPr indent="0" marL="0">
+            <a:pPr marL="0" indent="0">
               <a:buNone/>
             </a:pPr>
             <a:r>
@@ -6820,7 +6660,7 @@
             <a:endParaRPr lang="en-US" sz="1100" dirty="0"/>
           </a:p>
           <a:p>
-            <a:pPr indent="0" marL="0">
+            <a:pPr marL="0" indent="0">
               <a:buNone/>
             </a:pPr>
             <a:r>
@@ -6880,7 +6720,7 @@
           </a:solidFill>
           <a:ln/>
           <a:effectLst>
-            <a:outerShdw sx="100000" sy="100000" kx="0" ky="0" algn="bl" rotWithShape="0" blurRad="76200" dist="25400" dir="8100000">
+            <a:outerShdw blurRad="76200" dist="25400" dir="8100000" algn="bl" rotWithShape="0">
               <a:srgbClr val="000000">
                 <a:alpha val="12000"/>
               </a:srgbClr>
@@ -6929,7 +6769,7 @@
           <a:bodyPr wrap="square" rtlCol="0" anchor="ctr"/>
           <a:lstStyle/>
           <a:p>
-            <a:pPr algn="ctr" indent="0" marL="0">
+            <a:pPr marL="0" indent="0" algn="ctr">
               <a:buNone/>
             </a:pPr>
             <a:r>
@@ -6968,7 +6808,7 @@
           <a:bodyPr wrap="square" rtlCol="0" anchor="t"/>
           <a:lstStyle/>
           <a:p>
-            <a:pPr indent="0" marL="0">
+            <a:pPr marL="0" indent="0">
               <a:buNone/>
             </a:pPr>
             <a:r>
@@ -6985,7 +6825,7 @@
             <a:endParaRPr lang="en-US" sz="1100" dirty="0"/>
           </a:p>
           <a:p>
-            <a:pPr indent="0" marL="0">
+            <a:pPr marL="0" indent="0">
               <a:buNone/>
             </a:pPr>
             <a:r>
@@ -7002,7 +6842,7 @@
             <a:endParaRPr lang="en-US" sz="1100" dirty="0"/>
           </a:p>
           <a:p>
-            <a:pPr indent="0" marL="0">
+            <a:pPr marL="0" indent="0">
               <a:buNone/>
             </a:pPr>
             <a:r>
@@ -7062,7 +6902,7 @@
           </a:solidFill>
           <a:ln/>
           <a:effectLst>
-            <a:outerShdw sx="100000" sy="100000" kx="0" ky="0" algn="bl" rotWithShape="0" blurRad="76200" dist="25400" dir="8100000">
+            <a:outerShdw blurRad="76200" dist="25400" dir="8100000" algn="bl" rotWithShape="0">
               <a:srgbClr val="000000">
                 <a:alpha val="12000"/>
               </a:srgbClr>
@@ -7111,7 +6951,7 @@
           <a:bodyPr wrap="square" rtlCol="0" anchor="ctr"/>
           <a:lstStyle/>
           <a:p>
-            <a:pPr algn="ctr" indent="0" marL="0">
+            <a:pPr marL="0" indent="0" algn="ctr">
               <a:buNone/>
             </a:pPr>
             <a:r>
@@ -7150,7 +6990,7 @@
           <a:bodyPr wrap="square" rtlCol="0" anchor="t"/>
           <a:lstStyle/>
           <a:p>
-            <a:pPr indent="0" marL="0">
+            <a:pPr marL="0" indent="0">
               <a:buNone/>
             </a:pPr>
             <a:r>
@@ -7167,7 +7007,7 @@
             <a:endParaRPr lang="en-US" sz="1100" dirty="0"/>
           </a:p>
           <a:p>
-            <a:pPr indent="0" marL="0">
+            <a:pPr marL="0" indent="0">
               <a:buNone/>
             </a:pPr>
             <a:r>
@@ -7184,7 +7024,7 @@
             <a:endParaRPr lang="en-US" sz="1100" dirty="0"/>
           </a:p>
           <a:p>
-            <a:pPr indent="0" marL="0">
+            <a:pPr marL="0" indent="0">
               <a:buNone/>
             </a:pPr>
             <a:r>
@@ -7244,7 +7084,7 @@
           </a:solidFill>
           <a:ln/>
           <a:effectLst>
-            <a:outerShdw sx="100000" sy="100000" kx="0" ky="0" algn="bl" rotWithShape="0" blurRad="76200" dist="25400" dir="8100000">
+            <a:outerShdw blurRad="76200" dist="25400" dir="8100000" algn="bl" rotWithShape="0">
               <a:srgbClr val="000000">
                 <a:alpha val="12000"/>
               </a:srgbClr>
@@ -7293,7 +7133,7 @@
           <a:bodyPr wrap="square" rtlCol="0" anchor="ctr"/>
           <a:lstStyle/>
           <a:p>
-            <a:pPr algn="ctr" indent="0" marL="0">
+            <a:pPr marL="0" indent="0" algn="ctr">
               <a:buNone/>
             </a:pPr>
             <a:r>
@@ -7332,7 +7172,7 @@
           <a:bodyPr wrap="square" rtlCol="0" anchor="t"/>
           <a:lstStyle/>
           <a:p>
-            <a:pPr indent="0" marL="0">
+            <a:pPr marL="0" indent="0">
               <a:buNone/>
             </a:pPr>
             <a:r>
@@ -7349,7 +7189,7 @@
             <a:endParaRPr lang="en-US" sz="1100" dirty="0"/>
           </a:p>
           <a:p>
-            <a:pPr indent="0" marL="0">
+            <a:pPr marL="0" indent="0">
               <a:buNone/>
             </a:pPr>
             <a:r>
@@ -7366,7 +7206,7 @@
             <a:endParaRPr lang="en-US" sz="1100" dirty="0"/>
           </a:p>
           <a:p>
-            <a:pPr indent="0" marL="0">
+            <a:pPr marL="0" indent="0">
               <a:buNone/>
             </a:pPr>
             <a:r>
@@ -7426,7 +7266,7 @@
           </a:solidFill>
           <a:ln/>
           <a:effectLst>
-            <a:outerShdw sx="100000" sy="100000" kx="0" ky="0" algn="bl" rotWithShape="0" blurRad="76200" dist="25400" dir="8100000">
+            <a:outerShdw blurRad="76200" dist="25400" dir="8100000" algn="bl" rotWithShape="0">
               <a:srgbClr val="000000">
                 <a:alpha val="12000"/>
               </a:srgbClr>
@@ -7475,7 +7315,7 @@
           <a:bodyPr wrap="square" rtlCol="0" anchor="ctr"/>
           <a:lstStyle/>
           <a:p>
-            <a:pPr algn="ctr" indent="0" marL="0">
+            <a:pPr marL="0" indent="0" algn="ctr">
               <a:buNone/>
             </a:pPr>
             <a:r>
@@ -7514,7 +7354,7 @@
           <a:bodyPr wrap="square" rtlCol="0" anchor="t"/>
           <a:lstStyle/>
           <a:p>
-            <a:pPr indent="0" marL="0">
+            <a:pPr marL="0" indent="0">
               <a:buNone/>
             </a:pPr>
             <a:r>
@@ -7531,7 +7371,7 @@
             <a:endParaRPr lang="en-US" sz="1100" dirty="0"/>
           </a:p>
           <a:p>
-            <a:pPr indent="0" marL="0">
+            <a:pPr marL="0" indent="0">
               <a:buNone/>
             </a:pPr>
             <a:r>
@@ -7548,7 +7388,7 @@
             <a:endParaRPr lang="en-US" sz="1100" dirty="0"/>
           </a:p>
           <a:p>
-            <a:pPr indent="0" marL="0">
+            <a:pPr marL="0" indent="0">
               <a:buNone/>
             </a:pPr>
             <a:r>
@@ -7585,7 +7425,7 @@
           </a:solidFill>
           <a:ln/>
           <a:effectLst>
-            <a:outerShdw sx="100000" sy="100000" kx="0" ky="0" algn="bl" rotWithShape="0" blurRad="76200" dist="25400" dir="8100000">
+            <a:outerShdw blurRad="76200" dist="25400" dir="8100000" algn="bl" rotWithShape="0">
               <a:srgbClr val="000000">
                 <a:alpha val="12000"/>
               </a:srgbClr>
@@ -7634,7 +7474,7 @@
           <a:bodyPr wrap="square" rtlCol="0" anchor="ctr"/>
           <a:lstStyle/>
           <a:p>
-            <a:pPr indent="0" marL="0">
+            <a:pPr marL="0" indent="0">
               <a:buNone/>
             </a:pPr>
             <a:r>
@@ -7651,7 +7491,7 @@
             <a:endParaRPr lang="en-US" sz="1200" dirty="0"/>
           </a:p>
           <a:p>
-            <a:pPr indent="0" marL="0">
+            <a:pPr marL="0" indent="0">
               <a:buNone/>
             </a:pPr>
             <a:r>
@@ -7685,6 +7525,7 @@
         <a:solidFill>
           <a:srgbClr val="F4F7FA"/>
         </a:solidFill>
+        <a:effectLst/>
       </p:bgPr>
     </p:bg>
     <p:spTree>
@@ -7722,7 +7563,7 @@
           <a:bodyPr wrap="square" lIns="0" tIns="0" rIns="0" bIns="0" rtlCol="0" anchor="ctr"/>
           <a:lstStyle/>
           <a:p>
-            <a:pPr indent="0" marL="0">
+            <a:pPr marL="0" indent="0">
               <a:buNone/>
             </a:pPr>
             <a:r>
@@ -7779,7 +7620,7 @@
           </a:solidFill>
           <a:ln/>
           <a:effectLst>
-            <a:outerShdw sx="100000" sy="100000" kx="0" ky="0" algn="bl" rotWithShape="0" blurRad="76200" dist="25400" dir="8100000">
+            <a:outerShdw blurRad="76200" dist="25400" dir="8100000" algn="bl" rotWithShape="0">
               <a:srgbClr val="000000">
                 <a:alpha val="12000"/>
               </a:srgbClr>
@@ -7828,7 +7669,7 @@
           <a:bodyPr wrap="square" rtlCol="0" anchor="ctr"/>
           <a:lstStyle/>
           <a:p>
-            <a:pPr algn="ctr" indent="0" marL="0">
+            <a:pPr marL="0" indent="0" algn="ctr">
               <a:buNone/>
             </a:pPr>
             <a:r>
@@ -7867,7 +7708,7 @@
           <a:bodyPr wrap="square" rtlCol="0" anchor="ctr"/>
           <a:lstStyle/>
           <a:p>
-            <a:pPr algn="ctr" indent="0" marL="0">
+            <a:pPr marL="0" indent="0" algn="ctr">
               <a:buNone/>
             </a:pPr>
             <a:r>
@@ -7906,7 +7747,7 @@
           <a:bodyPr wrap="square" rtlCol="0" anchor="t"/>
           <a:lstStyle/>
           <a:p>
-            <a:pPr indent="0" marL="0">
+            <a:pPr marL="0" indent="0">
               <a:buNone/>
             </a:pPr>
             <a:r>
@@ -7923,7 +7764,7 @@
             <a:endParaRPr lang="en-US" sz="1100" dirty="0"/>
           </a:p>
           <a:p>
-            <a:pPr indent="0" marL="0">
+            <a:pPr marL="0" indent="0">
               <a:buNone/>
             </a:pPr>
             <a:r>
@@ -7940,7 +7781,7 @@
             <a:endParaRPr lang="en-US" sz="1100" dirty="0"/>
           </a:p>
           <a:p>
-            <a:pPr indent="0" marL="0">
+            <a:pPr marL="0" indent="0">
               <a:buNone/>
             </a:pPr>
             <a:r>
@@ -7957,7 +7798,7 @@
             <a:endParaRPr lang="en-US" sz="1100" dirty="0"/>
           </a:p>
           <a:p>
-            <a:pPr indent="0" marL="0">
+            <a:pPr marL="0" indent="0">
               <a:buNone/>
             </a:pPr>
             <a:r>
@@ -7994,7 +7835,7 @@
           </a:solidFill>
           <a:ln/>
           <a:effectLst>
-            <a:outerShdw sx="100000" sy="100000" kx="0" ky="0" algn="bl" rotWithShape="0" blurRad="76200" dist="25400" dir="8100000">
+            <a:outerShdw blurRad="76200" dist="25400" dir="8100000" algn="bl" rotWithShape="0">
               <a:srgbClr val="000000">
                 <a:alpha val="12000"/>
               </a:srgbClr>
@@ -8043,7 +7884,7 @@
           <a:bodyPr wrap="square" rtlCol="0" anchor="ctr"/>
           <a:lstStyle/>
           <a:p>
-            <a:pPr algn="ctr" indent="0" marL="0">
+            <a:pPr marL="0" indent="0" algn="ctr">
               <a:buNone/>
             </a:pPr>
             <a:r>
@@ -8082,7 +7923,7 @@
           <a:bodyPr wrap="square" rtlCol="0" anchor="ctr"/>
           <a:lstStyle/>
           <a:p>
-            <a:pPr algn="ctr" indent="0" marL="0">
+            <a:pPr marL="0" indent="0" algn="ctr">
               <a:buNone/>
             </a:pPr>
             <a:r>
@@ -8121,7 +7962,7 @@
           <a:bodyPr wrap="square" rtlCol="0" anchor="t"/>
           <a:lstStyle/>
           <a:p>
-            <a:pPr indent="0" marL="0">
+            <a:pPr marL="0" indent="0">
               <a:buNone/>
             </a:pPr>
             <a:r>
@@ -8138,7 +7979,7 @@
             <a:endParaRPr lang="en-US" sz="1100" dirty="0"/>
           </a:p>
           <a:p>
-            <a:pPr indent="0" marL="0">
+            <a:pPr marL="0" indent="0">
               <a:buNone/>
             </a:pPr>
             <a:r>
@@ -8155,7 +7996,7 @@
             <a:endParaRPr lang="en-US" sz="1100" dirty="0"/>
           </a:p>
           <a:p>
-            <a:pPr indent="0" marL="0">
+            <a:pPr marL="0" indent="0">
               <a:buNone/>
             </a:pPr>
             <a:r>
@@ -8172,7 +8013,7 @@
             <a:endParaRPr lang="en-US" sz="1100" dirty="0"/>
           </a:p>
           <a:p>
-            <a:pPr indent="0" marL="0">
+            <a:pPr marL="0" indent="0">
               <a:buNone/>
             </a:pPr>
             <a:r>
@@ -8209,7 +8050,7 @@
           </a:solidFill>
           <a:ln/>
           <a:effectLst>
-            <a:outerShdw sx="100000" sy="100000" kx="0" ky="0" algn="bl" rotWithShape="0" blurRad="76200" dist="25400" dir="8100000">
+            <a:outerShdw blurRad="76200" dist="25400" dir="8100000" algn="bl" rotWithShape="0">
               <a:srgbClr val="000000">
                 <a:alpha val="12000"/>
               </a:srgbClr>
@@ -8258,7 +8099,7 @@
           <a:bodyPr wrap="square" rtlCol="0" anchor="ctr"/>
           <a:lstStyle/>
           <a:p>
-            <a:pPr algn="ctr" indent="0" marL="0">
+            <a:pPr marL="0" indent="0" algn="ctr">
               <a:buNone/>
             </a:pPr>
             <a:r>
@@ -8297,7 +8138,7 @@
           <a:bodyPr wrap="square" rtlCol="0" anchor="ctr"/>
           <a:lstStyle/>
           <a:p>
-            <a:pPr algn="ctr" indent="0" marL="0">
+            <a:pPr marL="0" indent="0" algn="ctr">
               <a:buNone/>
             </a:pPr>
             <a:r>
@@ -8336,7 +8177,7 @@
           <a:bodyPr wrap="square" rtlCol="0" anchor="t"/>
           <a:lstStyle/>
           <a:p>
-            <a:pPr indent="0" marL="0">
+            <a:pPr marL="0" indent="0">
               <a:buNone/>
             </a:pPr>
             <a:r>
@@ -8353,7 +8194,7 @@
             <a:endParaRPr lang="en-US" sz="1100" dirty="0"/>
           </a:p>
           <a:p>
-            <a:pPr indent="0" marL="0">
+            <a:pPr marL="0" indent="0">
               <a:buNone/>
             </a:pPr>
             <a:r>
@@ -8370,7 +8211,7 @@
             <a:endParaRPr lang="en-US" sz="1100" dirty="0"/>
           </a:p>
           <a:p>
-            <a:pPr indent="0" marL="0">
+            <a:pPr marL="0" indent="0">
               <a:buNone/>
             </a:pPr>
             <a:r>
@@ -8387,7 +8228,7 @@
             <a:endParaRPr lang="en-US" sz="1100" dirty="0"/>
           </a:p>
           <a:p>
-            <a:pPr indent="0" marL="0">
+            <a:pPr marL="0" indent="0">
               <a:buNone/>
             </a:pPr>
             <a:r>
@@ -8424,7 +8265,7 @@
           </a:solidFill>
           <a:ln/>
           <a:effectLst>
-            <a:outerShdw sx="100000" sy="100000" kx="0" ky="0" algn="bl" rotWithShape="0" blurRad="76200" dist="25400" dir="8100000">
+            <a:outerShdw blurRad="76200" dist="25400" dir="8100000" algn="bl" rotWithShape="0">
               <a:srgbClr val="000000">
                 <a:alpha val="12000"/>
               </a:srgbClr>
@@ -8473,7 +8314,7 @@
           <a:bodyPr wrap="square" rtlCol="0" anchor="ctr"/>
           <a:lstStyle/>
           <a:p>
-            <a:pPr algn="ctr" indent="0" marL="0">
+            <a:pPr marL="0" indent="0" algn="ctr">
               <a:buNone/>
             </a:pPr>
             <a:r>
@@ -8512,7 +8353,7 @@
           <a:bodyPr wrap="square" rtlCol="0" anchor="ctr"/>
           <a:lstStyle/>
           <a:p>
-            <a:pPr algn="ctr" indent="0" marL="0">
+            <a:pPr marL="0" indent="0" algn="ctr">
               <a:buNone/>
             </a:pPr>
             <a:r>
@@ -8551,7 +8392,7 @@
           <a:bodyPr wrap="square" rtlCol="0" anchor="t"/>
           <a:lstStyle/>
           <a:p>
-            <a:pPr indent="0" marL="0">
+            <a:pPr marL="0" indent="0">
               <a:buNone/>
             </a:pPr>
             <a:r>
@@ -8568,7 +8409,7 @@
             <a:endParaRPr lang="en-US" sz="1100" dirty="0"/>
           </a:p>
           <a:p>
-            <a:pPr indent="0" marL="0">
+            <a:pPr marL="0" indent="0">
               <a:buNone/>
             </a:pPr>
             <a:r>
@@ -8585,7 +8426,7 @@
             <a:endParaRPr lang="en-US" sz="1100" dirty="0"/>
           </a:p>
           <a:p>
-            <a:pPr indent="0" marL="0">
+            <a:pPr marL="0" indent="0">
               <a:buNone/>
             </a:pPr>
             <a:r>
@@ -8602,7 +8443,7 @@
             <a:endParaRPr lang="en-US" sz="1100" dirty="0"/>
           </a:p>
           <a:p>
-            <a:pPr indent="0" marL="0">
+            <a:pPr marL="0" indent="0">
               <a:buNone/>
             </a:pPr>
             <a:r>
@@ -8636,6 +8477,7 @@
         <a:solidFill>
           <a:srgbClr val="F4F7FA"/>
         </a:solidFill>
+        <a:effectLst/>
       </p:bgPr>
     </p:bg>
     <p:spTree>
@@ -8673,7 +8515,7 @@
           <a:bodyPr wrap="square" lIns="0" tIns="0" rIns="0" bIns="0" rtlCol="0" anchor="ctr"/>
           <a:lstStyle/>
           <a:p>
-            <a:pPr indent="0" marL="0">
+            <a:pPr marL="0" indent="0">
               <a:buNone/>
             </a:pPr>
             <a:r>
@@ -8730,7 +8572,7 @@
           </a:solidFill>
           <a:ln/>
           <a:effectLst>
-            <a:outerShdw sx="100000" sy="100000" kx="0" ky="0" algn="bl" rotWithShape="0" blurRad="76200" dist="25400" dir="8100000">
+            <a:outerShdw blurRad="76200" dist="25400" dir="8100000" algn="bl" rotWithShape="0">
               <a:srgbClr val="000000">
                 <a:alpha val="12000"/>
               </a:srgbClr>
@@ -8779,7 +8621,7 @@
           <a:bodyPr wrap="square" rtlCol="0" anchor="ctr"/>
           <a:lstStyle/>
           <a:p>
-            <a:pPr algn="ctr" indent="0" marL="0">
+            <a:pPr marL="0" indent="0" algn="ctr">
               <a:buNone/>
             </a:pPr>
             <a:r>
@@ -8818,7 +8660,7 @@
           <a:bodyPr wrap="square" rtlCol="0" anchor="ctr"/>
           <a:lstStyle/>
           <a:p>
-            <a:pPr indent="0" marL="0">
+            <a:pPr marL="0" indent="0">
               <a:buNone/>
             </a:pPr>
             <a:r>
@@ -8835,7 +8677,7 @@
             <a:endParaRPr lang="en-US" sz="1100" dirty="0"/>
           </a:p>
           <a:p>
-            <a:pPr indent="0" marL="0">
+            <a:pPr marL="0" indent="0">
               <a:buNone/>
             </a:pPr>
             <a:r>
@@ -8852,7 +8694,7 @@
             <a:endParaRPr lang="en-US" sz="1100" dirty="0"/>
           </a:p>
           <a:p>
-            <a:pPr indent="0" marL="0">
+            <a:pPr marL="0" indent="0">
               <a:buNone/>
             </a:pPr>
             <a:r>
@@ -8869,7 +8711,7 @@
             <a:endParaRPr lang="en-US" sz="1100" dirty="0"/>
           </a:p>
           <a:p>
-            <a:pPr indent="0" marL="0">
+            <a:pPr marL="0" indent="0">
               <a:buNone/>
             </a:pPr>
             <a:r>
@@ -8886,7 +8728,7 @@
             <a:endParaRPr lang="en-US" sz="1100" dirty="0"/>
           </a:p>
           <a:p>
-            <a:pPr indent="0" marL="0">
+            <a:pPr marL="0" indent="0">
               <a:buNone/>
             </a:pPr>
             <a:r>
@@ -8903,7 +8745,7 @@
             <a:endParaRPr lang="en-US" sz="1100" dirty="0"/>
           </a:p>
           <a:p>
-            <a:pPr indent="0" marL="0">
+            <a:pPr marL="0" indent="0">
               <a:buNone/>
             </a:pPr>
             <a:r>
@@ -8940,7 +8782,7 @@
           </a:solidFill>
           <a:ln/>
           <a:effectLst>
-            <a:outerShdw sx="100000" sy="100000" kx="0" ky="0" algn="bl" rotWithShape="0" blurRad="76200" dist="25400" dir="8100000">
+            <a:outerShdw blurRad="76200" dist="25400" dir="8100000" algn="bl" rotWithShape="0">
               <a:srgbClr val="000000">
                 <a:alpha val="12000"/>
               </a:srgbClr>
@@ -8989,7 +8831,7 @@
           <a:bodyPr wrap="square" rtlCol="0" anchor="ctr"/>
           <a:lstStyle/>
           <a:p>
-            <a:pPr algn="ctr" indent="0" marL="0">
+            <a:pPr marL="0" indent="0" algn="ctr">
               <a:buNone/>
             </a:pPr>
             <a:r>
@@ -9028,7 +8870,7 @@
           <a:bodyPr wrap="square" rtlCol="0" anchor="ctr"/>
           <a:lstStyle/>
           <a:p>
-            <a:pPr indent="0" marL="0">
+            <a:pPr marL="0" indent="0">
               <a:buNone/>
             </a:pPr>
             <a:r>
@@ -9045,7 +8887,7 @@
             <a:endParaRPr lang="en-US" sz="1100" dirty="0"/>
           </a:p>
           <a:p>
-            <a:pPr indent="0" marL="0">
+            <a:pPr marL="0" indent="0">
               <a:buNone/>
             </a:pPr>
             <a:r>
@@ -9062,7 +8904,7 @@
             <a:endParaRPr lang="en-US" sz="1100" dirty="0"/>
           </a:p>
           <a:p>
-            <a:pPr indent="0" marL="0">
+            <a:pPr marL="0" indent="0">
               <a:buNone/>
             </a:pPr>
             <a:r>
@@ -9079,7 +8921,7 @@
             <a:endParaRPr lang="en-US" sz="1100" dirty="0"/>
           </a:p>
           <a:p>
-            <a:pPr indent="0" marL="0">
+            <a:pPr marL="0" indent="0">
               <a:buNone/>
             </a:pPr>
             <a:r>
@@ -9096,7 +8938,7 @@
             <a:endParaRPr lang="en-US" sz="1100" dirty="0"/>
           </a:p>
           <a:p>
-            <a:pPr indent="0" marL="0">
+            <a:pPr marL="0" indent="0">
               <a:buNone/>
             </a:pPr>
             <a:r>
@@ -9113,7 +8955,7 @@
             <a:endParaRPr lang="en-US" sz="1100" dirty="0"/>
           </a:p>
           <a:p>
-            <a:pPr indent="0" marL="0">
+            <a:pPr marL="0" indent="0">
               <a:buNone/>
             </a:pPr>
             <a:r>
@@ -9150,7 +8992,7 @@
           </a:solidFill>
           <a:ln/>
           <a:effectLst>
-            <a:outerShdw sx="100000" sy="100000" kx="0" ky="0" algn="bl" rotWithShape="0" blurRad="76200" dist="25400" dir="8100000">
+            <a:outerShdw blurRad="76200" dist="25400" dir="8100000" algn="bl" rotWithShape="0">
               <a:srgbClr val="000000">
                 <a:alpha val="12000"/>
               </a:srgbClr>
@@ -9199,7 +9041,7 @@
           <a:bodyPr wrap="square" rtlCol="0" anchor="ctr"/>
           <a:lstStyle/>
           <a:p>
-            <a:pPr algn="ctr" indent="0" marL="0">
+            <a:pPr marL="0" indent="0" algn="ctr">
               <a:buNone/>
             </a:pPr>
             <a:r>
@@ -9219,30 +9061,48 @@
       </p:sp>
       <p:graphicFrame>
         <p:nvGraphicFramePr>
-          <p:cNvPr id="9" name="Table 0"/>
+          <p:cNvPr id="15" name="Table 0"/>
           <p:cNvGraphicFramePr>
             <a:graphicFrameLocks noGrp="1"/>
           </p:cNvGraphicFramePr>
           <p:nvPr>
             <p:extLst>
               <p:ext uri="{D42A27DB-BD31-4B8C-83A1-F6EECF244321}">
-                <p14:modId xmlns:p14="http://schemas.microsoft.com/office/powerpoint/2010/main" val="1579011935"/>
+                <p14:modId xmlns:p14="http://schemas.microsoft.com/office/powerpoint/2010/main" val="401885360"/>
               </p:ext>
             </p:extLst>
           </p:nvPr>
         </p:nvGraphicFramePr>
         <p:xfrm>
           <a:off x="822960" y="3840480"/>
-          <a:ext cx="7498080" cy="914400"/>
+          <a:ext cx="7498080" cy="1036320"/>
         </p:xfrm>
         <a:graphic>
           <a:graphicData uri="http://schemas.openxmlformats.org/drawingml/2006/table">
             <a:tbl>
               <a:tblPr/>
               <a:tblGrid>
-                <a:gridCol w="1371600"/>
-                <a:gridCol w="2286000"/>
-                <a:gridCol w="3840480"/>
+                <a:gridCol w="1371600">
+                  <a:extLst>
+                    <a:ext uri="{9D8B030D-6E8A-4147-A177-3AD203B41FA5}">
+                      <a16:colId xmlns:a16="http://schemas.microsoft.com/office/drawing/2014/main" val="20000"/>
+                    </a:ext>
+                  </a:extLst>
+                </a:gridCol>
+                <a:gridCol w="2286000">
+                  <a:extLst>
+                    <a:ext uri="{9D8B030D-6E8A-4147-A177-3AD203B41FA5}">
+                      <a16:colId xmlns:a16="http://schemas.microsoft.com/office/drawing/2014/main" val="20001"/>
+                    </a:ext>
+                  </a:extLst>
+                </a:gridCol>
+                <a:gridCol w="3840480">
+                  <a:extLst>
+                    <a:ext uri="{9D8B030D-6E8A-4147-A177-3AD203B41FA5}">
+                      <a16:colId xmlns:a16="http://schemas.microsoft.com/office/drawing/2014/main" val="20002"/>
+                    </a:ext>
+                  </a:extLst>
+                </a:gridCol>
               </a:tblGrid>
               <a:tr h="256032">
                 <a:tc>
@@ -9250,7 +9110,7 @@
                     <a:bodyPr/>
                     <a:lstStyle/>
                     <a:p>
-                      <a:pPr indent="0" marL="0">
+                      <a:pPr marL="0" indent="0">
                         <a:buNone/>
                       </a:pPr>
                       <a:r>
@@ -9271,7 +9131,7 @@
                       </a:endParaRPr>
                     </a:p>
                   </a:txBody>
-                  <a:tcPr marL="91440" marR="91440" marT="45720" marB="45720">
+                  <a:tcPr>
                     <a:lnL w="6350" cap="flat" cmpd="sng" algn="ctr">
                       <a:solidFill>
                         <a:srgbClr val="D0D5DD"/>
@@ -9318,7 +9178,7 @@
                     <a:bodyPr/>
                     <a:lstStyle/>
                     <a:p>
-                      <a:pPr indent="0" marL="0">
+                      <a:pPr marL="0" indent="0">
                         <a:buNone/>
                       </a:pPr>
                       <a:r>
@@ -9339,7 +9199,7 @@
                       </a:endParaRPr>
                     </a:p>
                   </a:txBody>
-                  <a:tcPr marL="91440" marR="91440" marT="45720" marB="45720">
+                  <a:tcPr>
                     <a:lnL w="6350" cap="flat" cmpd="sng" algn="ctr">
                       <a:solidFill>
                         <a:srgbClr val="D0D5DD"/>
@@ -9386,7 +9246,7 @@
                     <a:bodyPr/>
                     <a:lstStyle/>
                     <a:p>
-                      <a:pPr indent="0" marL="0">
+                      <a:pPr marL="0" indent="0">
                         <a:buNone/>
                       </a:pPr>
                       <a:r>
@@ -9407,7 +9267,7 @@
                       </a:endParaRPr>
                     </a:p>
                   </a:txBody>
-                  <a:tcPr marL="91440" marR="91440" marT="45720" marB="45720">
+                  <a:tcPr>
                     <a:lnL w="6350" cap="flat" cmpd="sng" algn="ctr">
                       <a:solidFill>
                         <a:srgbClr val="D0D5DD"/>
@@ -9449,6 +9309,11 @@
                     </a:solidFill>
                   </a:tcPr>
                 </a:tc>
+                <a:extLst>
+                  <a:ext uri="{0D108BD9-81ED-4DB2-BD59-A6C34878D82A}">
+                    <a16:rowId xmlns:a16="http://schemas.microsoft.com/office/drawing/2014/main" val="10000"/>
+                  </a:ext>
+                </a:extLst>
               </a:tr>
               <a:tr h="256032">
                 <a:tc>
@@ -9456,7 +9321,7 @@
                     <a:bodyPr/>
                     <a:lstStyle/>
                     <a:p>
-                      <a:pPr indent="0" marL="0">
+                      <a:pPr marL="0" indent="0">
                         <a:buNone/>
                       </a:pPr>
                       <a:r>
@@ -9477,7 +9342,7 @@
                       </a:endParaRPr>
                     </a:p>
                   </a:txBody>
-                  <a:tcPr marL="91440" marR="91440" marT="45720" marB="45720">
+                  <a:tcPr>
                     <a:lnL w="6350" cap="flat" cmpd="sng" algn="ctr">
                       <a:solidFill>
                         <a:srgbClr val="D0D5DD"/>
@@ -9521,7 +9386,7 @@
                     <a:bodyPr/>
                     <a:lstStyle/>
                     <a:p>
-                      <a:pPr indent="0" marL="0">
+                      <a:pPr marL="0" indent="0">
                         <a:buNone/>
                       </a:pPr>
                       <a:r>
@@ -9542,7 +9407,7 @@
                       </a:endParaRPr>
                     </a:p>
                   </a:txBody>
-                  <a:tcPr marL="91440" marR="91440" marT="45720" marB="45720">
+                  <a:tcPr>
                     <a:lnL w="6350" cap="flat" cmpd="sng" algn="ctr">
                       <a:solidFill>
                         <a:srgbClr val="D0D5DD"/>
@@ -9586,7 +9451,7 @@
                     <a:bodyPr/>
                     <a:lstStyle/>
                     <a:p>
-                      <a:pPr indent="0" marL="0">
+                      <a:pPr marL="0" indent="0">
                         <a:buNone/>
                       </a:pPr>
                       <a:r>
@@ -9607,7 +9472,7 @@
                       </a:endParaRPr>
                     </a:p>
                   </a:txBody>
-                  <a:tcPr marL="91440" marR="91440" marT="45720" marB="45720">
+                  <a:tcPr>
                     <a:lnL w="6350" cap="flat" cmpd="sng" algn="ctr">
                       <a:solidFill>
                         <a:srgbClr val="D0D5DD"/>
@@ -9646,6 +9511,11 @@
                     </a:lnB>
                   </a:tcPr>
                 </a:tc>
+                <a:extLst>
+                  <a:ext uri="{0D108BD9-81ED-4DB2-BD59-A6C34878D82A}">
+                    <a16:rowId xmlns:a16="http://schemas.microsoft.com/office/drawing/2014/main" val="10001"/>
+                  </a:ext>
+                </a:extLst>
               </a:tr>
               <a:tr h="256032">
                 <a:tc>
@@ -9653,7 +9523,7 @@
                     <a:bodyPr/>
                     <a:lstStyle/>
                     <a:p>
-                      <a:pPr indent="0" marL="0">
+                      <a:pPr marL="0" indent="0">
                         <a:buNone/>
                       </a:pPr>
                       <a:r>
@@ -9674,7 +9544,7 @@
                       </a:endParaRPr>
                     </a:p>
                   </a:txBody>
-                  <a:tcPr marL="91440" marR="91440" marT="45720" marB="45720">
+                  <a:tcPr>
                     <a:lnL w="6350" cap="flat" cmpd="sng" algn="ctr">
                       <a:solidFill>
                         <a:srgbClr val="D0D5DD"/>
@@ -9718,7 +9588,7 @@
                     <a:bodyPr/>
                     <a:lstStyle/>
                     <a:p>
-                      <a:pPr indent="0" marL="0">
+                      <a:pPr marL="0" indent="0">
                         <a:buNone/>
                       </a:pPr>
                       <a:r>
@@ -9739,7 +9609,7 @@
                       </a:endParaRPr>
                     </a:p>
                   </a:txBody>
-                  <a:tcPr marL="91440" marR="91440" marT="45720" marB="45720">
+                  <a:tcPr>
                     <a:lnL w="6350" cap="flat" cmpd="sng" algn="ctr">
                       <a:solidFill>
                         <a:srgbClr val="D0D5DD"/>
@@ -9783,9 +9653,20 @@
                     <a:bodyPr/>
                     <a:lstStyle/>
                     <a:p>
-                      <a:pPr indent="0" marL="0">
+                      <a:pPr marL="0" indent="0">
                         <a:buNone/>
                       </a:pPr>
+                      <a:r>
+                        <a:rPr lang="en-US" sz="1100">
+                          <a:solidFill>
+                            <a:srgbClr val="1E293B"/>
+                          </a:solidFill>
+                          <a:latin typeface="Calibri" pitchFamily="34" charset="0"/>
+                          <a:ea typeface="Calibri" pitchFamily="34" charset="-122"/>
+                          <a:cs typeface="Calibri" pitchFamily="34" charset="-120"/>
+                        </a:rPr>
+                        <a:t>18650 </a:t>
+                      </a:r>
                       <a:r>
                         <a:rPr lang="en-US" sz="1100" dirty="0">
                           <a:solidFill>
@@ -9795,7 +9676,7 @@
                           <a:ea typeface="Calibri" pitchFamily="34" charset="-122"/>
                           <a:cs typeface="Calibri" pitchFamily="34" charset="-120"/>
                         </a:rPr>
-                        <a:t>ICR18650-22P 額定容量</a:t>
+                        <a:t>額定容量</a:t>
                       </a:r>
                       <a:endParaRPr lang="en-US" sz="1100" dirty="0">
                         <a:latin typeface="Calibri" charset="0"/>
@@ -9804,7 +9685,7 @@
                       </a:endParaRPr>
                     </a:p>
                   </a:txBody>
-                  <a:tcPr marL="91440" marR="91440" marT="45720" marB="45720">
+                  <a:tcPr>
                     <a:lnL w="6350" cap="flat" cmpd="sng" algn="ctr">
                       <a:solidFill>
                         <a:srgbClr val="D0D5DD"/>
@@ -9843,6 +9724,11 @@
                     </a:lnB>
                   </a:tcPr>
                 </a:tc>
+                <a:extLst>
+                  <a:ext uri="{0D108BD9-81ED-4DB2-BD59-A6C34878D82A}">
+                    <a16:rowId xmlns:a16="http://schemas.microsoft.com/office/drawing/2014/main" val="10002"/>
+                  </a:ext>
+                </a:extLst>
               </a:tr>
               <a:tr h="256032">
                 <a:tc>
@@ -9850,7 +9736,7 @@
                     <a:bodyPr/>
                     <a:lstStyle/>
                     <a:p>
-                      <a:pPr indent="0" marL="0">
+                      <a:pPr marL="0" indent="0">
                         <a:buNone/>
                       </a:pPr>
                       <a:r>
@@ -9871,7 +9757,7 @@
                       </a:endParaRPr>
                     </a:p>
                   </a:txBody>
-                  <a:tcPr marL="91440" marR="91440" marT="45720" marB="45720">
+                  <a:tcPr>
                     <a:lnL w="6350" cap="flat" cmpd="sng" algn="ctr">
                       <a:solidFill>
                         <a:srgbClr val="D0D5DD"/>
@@ -9915,7 +9801,7 @@
                     <a:bodyPr/>
                     <a:lstStyle/>
                     <a:p>
-                      <a:pPr indent="0" marL="0">
+                      <a:pPr marL="0" indent="0">
                         <a:buNone/>
                       </a:pPr>
                       <a:r>
@@ -9936,7 +9822,7 @@
                       </a:endParaRPr>
                     </a:p>
                   </a:txBody>
-                  <a:tcPr marL="91440" marR="91440" marT="45720" marB="45720">
+                  <a:tcPr>
                     <a:lnL w="6350" cap="flat" cmpd="sng" algn="ctr">
                       <a:solidFill>
                         <a:srgbClr val="D0D5DD"/>
@@ -9980,7 +9866,7 @@
                     <a:bodyPr/>
                     <a:lstStyle/>
                     <a:p>
-                      <a:pPr indent="0" marL="0">
+                      <a:pPr marL="0" indent="0">
                         <a:buNone/>
                       </a:pPr>
                       <a:r>
@@ -10001,7 +9887,7 @@
                       </a:endParaRPr>
                     </a:p>
                   </a:txBody>
-                  <a:tcPr marL="91440" marR="91440" marT="45720" marB="45720">
+                  <a:tcPr>
                     <a:lnL w="6350" cap="flat" cmpd="sng" algn="ctr">
                       <a:solidFill>
                         <a:srgbClr val="D0D5DD"/>
@@ -10040,6 +9926,11 @@
                     </a:lnB>
                   </a:tcPr>
                 </a:tc>
+                <a:extLst>
+                  <a:ext uri="{0D108BD9-81ED-4DB2-BD59-A6C34878D82A}">
+                    <a16:rowId xmlns:a16="http://schemas.microsoft.com/office/drawing/2014/main" val="10003"/>
+                  </a:ext>
+                </a:extLst>
               </a:tr>
             </a:tbl>
           </a:graphicData>
@@ -10061,6 +9952,7 @@
         <a:solidFill>
           <a:srgbClr val="F4F7FA"/>
         </a:solidFill>
+        <a:effectLst/>
       </p:bgPr>
     </p:bg>
     <p:spTree>
@@ -10098,7 +9990,7 @@
           <a:bodyPr wrap="square" lIns="0" tIns="0" rIns="0" bIns="0" rtlCol="0" anchor="ctr"/>
           <a:lstStyle/>
           <a:p>
-            <a:pPr indent="0" marL="0">
+            <a:pPr marL="0" indent="0">
               <a:buNone/>
             </a:pPr>
             <a:r>
@@ -10157,7 +10049,7 @@
           <a:bodyPr wrap="square" lIns="0" tIns="0" rIns="0" bIns="0" rtlCol="0" anchor="ctr"/>
           <a:lstStyle/>
           <a:p>
-            <a:pPr indent="0" marL="0">
+            <a:pPr marL="0" indent="0">
               <a:buNone/>
             </a:pPr>
             <a:r>
@@ -10194,7 +10086,7 @@
           </a:solidFill>
           <a:ln/>
           <a:effectLst>
-            <a:outerShdw sx="100000" sy="100000" kx="0" ky="0" algn="bl" rotWithShape="0" blurRad="76200" dist="25400" dir="8100000">
+            <a:outerShdw blurRad="76200" dist="25400" dir="8100000" algn="bl" rotWithShape="0">
               <a:srgbClr val="000000">
                 <a:alpha val="12000"/>
               </a:srgbClr>
@@ -10223,7 +10115,7 @@
           <a:bodyPr wrap="square" rtlCol="0" anchor="ctr"/>
           <a:lstStyle/>
           <a:p>
-            <a:pPr algn="ctr" indent="0" marL="0">
+            <a:pPr marL="0" indent="0" algn="ctr">
               <a:buNone/>
             </a:pPr>
             <a:r>
@@ -10262,7 +10154,7 @@
           <a:bodyPr wrap="square" rtlCol="0" anchor="ctr"/>
           <a:lstStyle/>
           <a:p>
-            <a:pPr algn="ctr" indent="0" marL="0">
+            <a:pPr marL="0" indent="0" algn="ctr">
               <a:buNone/>
             </a:pPr>
             <a:r>
@@ -10301,7 +10193,7 @@
           <a:bodyPr wrap="square" rtlCol="0" anchor="ctr"/>
           <a:lstStyle/>
           <a:p>
-            <a:pPr algn="ctr" indent="0" marL="0">
+            <a:pPr marL="0" indent="0" algn="ctr">
               <a:buNone/>
             </a:pPr>
             <a:r>
@@ -10338,7 +10230,7 @@
           </a:solidFill>
           <a:ln/>
           <a:effectLst>
-            <a:outerShdw sx="100000" sy="100000" kx="0" ky="0" algn="bl" rotWithShape="0" blurRad="76200" dist="25400" dir="8100000">
+            <a:outerShdw blurRad="76200" dist="25400" dir="8100000" algn="bl" rotWithShape="0">
               <a:srgbClr val="000000">
                 <a:alpha val="12000"/>
               </a:srgbClr>
@@ -10367,7 +10259,7 @@
           <a:bodyPr wrap="square" rtlCol="0" anchor="ctr"/>
           <a:lstStyle/>
           <a:p>
-            <a:pPr algn="ctr" indent="0" marL="0">
+            <a:pPr marL="0" indent="0" algn="ctr">
               <a:buNone/>
             </a:pPr>
             <a:r>
@@ -10406,7 +10298,7 @@
           <a:bodyPr wrap="square" rtlCol="0" anchor="ctr"/>
           <a:lstStyle/>
           <a:p>
-            <a:pPr algn="ctr" indent="0" marL="0">
+            <a:pPr marL="0" indent="0" algn="ctr">
               <a:buNone/>
             </a:pPr>
             <a:r>
@@ -10445,7 +10337,7 @@
           <a:bodyPr wrap="square" rtlCol="0" anchor="ctr"/>
           <a:lstStyle/>
           <a:p>
-            <a:pPr algn="ctr" indent="0" marL="0">
+            <a:pPr marL="0" indent="0" algn="ctr">
               <a:buNone/>
             </a:pPr>
             <a:r>
@@ -10482,7 +10374,7 @@
           </a:solidFill>
           <a:ln/>
           <a:effectLst>
-            <a:outerShdw sx="100000" sy="100000" kx="0" ky="0" algn="bl" rotWithShape="0" blurRad="76200" dist="25400" dir="8100000">
+            <a:outerShdw blurRad="76200" dist="25400" dir="8100000" algn="bl" rotWithShape="0">
               <a:srgbClr val="000000">
                 <a:alpha val="12000"/>
               </a:srgbClr>
@@ -10511,7 +10403,7 @@
           <a:bodyPr wrap="square" rtlCol="0" anchor="ctr"/>
           <a:lstStyle/>
           <a:p>
-            <a:pPr algn="ctr" indent="0" marL="0">
+            <a:pPr marL="0" indent="0" algn="ctr">
               <a:buNone/>
             </a:pPr>
             <a:r>
@@ -10550,7 +10442,7 @@
           <a:bodyPr wrap="square" rtlCol="0" anchor="ctr"/>
           <a:lstStyle/>
           <a:p>
-            <a:pPr algn="ctr" indent="0" marL="0">
+            <a:pPr marL="0" indent="0" algn="ctr">
               <a:buNone/>
             </a:pPr>
             <a:r>
@@ -10589,7 +10481,7 @@
           <a:bodyPr wrap="square" rtlCol="0" anchor="ctr"/>
           <a:lstStyle/>
           <a:p>
-            <a:pPr algn="ctr" indent="0" marL="0">
+            <a:pPr marL="0" indent="0" algn="ctr">
               <a:buNone/>
             </a:pPr>
             <a:r>
@@ -10628,7 +10520,7 @@
           <a:bodyPr wrap="square" lIns="0" tIns="0" rIns="0" bIns="0" rtlCol="0" anchor="ctr"/>
           <a:lstStyle/>
           <a:p>
-            <a:pPr indent="0" marL="0">
+            <a:pPr marL="0" indent="0">
               <a:buNone/>
             </a:pPr>
             <a:r>
@@ -10707,7 +10599,7 @@
           <a:bodyPr wrap="square" rtlCol="0" anchor="ctr"/>
           <a:lstStyle/>
           <a:p>
-            <a:pPr algn="ctr" indent="0" marL="0">
+            <a:pPr marL="0" indent="0" algn="ctr">
               <a:buNone/>
             </a:pPr>
             <a:r>
@@ -10746,7 +10638,7 @@
           <a:bodyPr wrap="square" rtlCol="0" anchor="t"/>
           <a:lstStyle/>
           <a:p>
-            <a:pPr algn="ctr" indent="0" marL="0">
+            <a:pPr marL="0" indent="0" algn="ctr">
               <a:buNone/>
             </a:pPr>
             <a:r>
@@ -10763,7 +10655,7 @@
             <a:endParaRPr lang="en-US" sz="1000" dirty="0"/>
           </a:p>
           <a:p>
-            <a:pPr algn="ctr" indent="0" marL="0">
+            <a:pPr marL="0" indent="0" algn="ctr">
               <a:buNone/>
             </a:pPr>
             <a:r>
@@ -10822,7 +10714,7 @@
           <a:bodyPr wrap="square" rtlCol="0" anchor="ctr"/>
           <a:lstStyle/>
           <a:p>
-            <a:pPr algn="ctr" indent="0" marL="0">
+            <a:pPr marL="0" indent="0" algn="ctr">
               <a:buNone/>
             </a:pPr>
             <a:r>
@@ -10861,7 +10753,7 @@
           <a:bodyPr wrap="square" rtlCol="0" anchor="t"/>
           <a:lstStyle/>
           <a:p>
-            <a:pPr algn="ctr" indent="0" marL="0">
+            <a:pPr marL="0" indent="0" algn="ctr">
               <a:buNone/>
             </a:pPr>
             <a:r>
@@ -10878,7 +10770,7 @@
             <a:endParaRPr lang="en-US" sz="1000" dirty="0"/>
           </a:p>
           <a:p>
-            <a:pPr algn="ctr" indent="0" marL="0">
+            <a:pPr marL="0" indent="0" algn="ctr">
               <a:buNone/>
             </a:pPr>
             <a:r>
@@ -10937,7 +10829,7 @@
           <a:bodyPr wrap="square" rtlCol="0" anchor="ctr"/>
           <a:lstStyle/>
           <a:p>
-            <a:pPr algn="ctr" indent="0" marL="0">
+            <a:pPr marL="0" indent="0" algn="ctr">
               <a:buNone/>
             </a:pPr>
             <a:r>
@@ -10976,7 +10868,7 @@
           <a:bodyPr wrap="square" rtlCol="0" anchor="t"/>
           <a:lstStyle/>
           <a:p>
-            <a:pPr algn="ctr" indent="0" marL="0">
+            <a:pPr marL="0" indent="0" algn="ctr">
               <a:buNone/>
             </a:pPr>
             <a:r>
@@ -10993,7 +10885,7 @@
             <a:endParaRPr lang="en-US" sz="1000" dirty="0"/>
           </a:p>
           <a:p>
-            <a:pPr algn="ctr" indent="0" marL="0">
+            <a:pPr marL="0" indent="0" algn="ctr">
               <a:buNone/>
             </a:pPr>
             <a:r>
@@ -11052,7 +10944,7 @@
           <a:bodyPr wrap="square" rtlCol="0" anchor="ctr"/>
           <a:lstStyle/>
           <a:p>
-            <a:pPr algn="ctr" indent="0" marL="0">
+            <a:pPr marL="0" indent="0" algn="ctr">
               <a:buNone/>
             </a:pPr>
             <a:r>
@@ -11091,7 +10983,7 @@
           <a:bodyPr wrap="square" rtlCol="0" anchor="t"/>
           <a:lstStyle/>
           <a:p>
-            <a:pPr algn="ctr" indent="0" marL="0">
+            <a:pPr marL="0" indent="0" algn="ctr">
               <a:buNone/>
             </a:pPr>
             <a:r>
@@ -11108,7 +11000,7 @@
             <a:endParaRPr lang="en-US" sz="1000" dirty="0"/>
           </a:p>
           <a:p>
-            <a:pPr algn="ctr" indent="0" marL="0">
+            <a:pPr marL="0" indent="0" algn="ctr">
               <a:buNone/>
             </a:pPr>
             <a:r>
@@ -11167,7 +11059,7 @@
           <a:bodyPr wrap="square" rtlCol="0" anchor="ctr"/>
           <a:lstStyle/>
           <a:p>
-            <a:pPr algn="ctr" indent="0" marL="0">
+            <a:pPr marL="0" indent="0" algn="ctr">
               <a:buNone/>
             </a:pPr>
             <a:r>
@@ -11206,7 +11098,7 @@
           <a:bodyPr wrap="square" rtlCol="0" anchor="t"/>
           <a:lstStyle/>
           <a:p>
-            <a:pPr algn="ctr" indent="0" marL="0">
+            <a:pPr marL="0" indent="0" algn="ctr">
               <a:buNone/>
             </a:pPr>
             <a:r>
@@ -11223,7 +11115,7 @@
             <a:endParaRPr lang="en-US" sz="1000" dirty="0"/>
           </a:p>
           <a:p>
-            <a:pPr algn="ctr" indent="0" marL="0">
+            <a:pPr marL="0" indent="0" algn="ctr">
               <a:buNone/>
             </a:pPr>
             <a:r>
@@ -11282,7 +11174,7 @@
           <a:bodyPr wrap="square" rtlCol="0" anchor="ctr"/>
           <a:lstStyle/>
           <a:p>
-            <a:pPr indent="0" marL="0">
+            <a:pPr marL="0" indent="0">
               <a:buNone/>
             </a:pPr>
             <a:r>
@@ -11601,4 +11493,299 @@
     </a:ext>
   </a:extLst>
 </a:theme>
+</file>
+
+<file path=ppt/theme/theme2.xml><?xml version="1.0" encoding="utf-8"?>
+<a:theme xmlns:a="http://schemas.openxmlformats.org/drawingml/2006/main" name="Office 佈景主題">
+  <a:themeElements>
+    <a:clrScheme name="Office">
+      <a:dk1>
+        <a:sysClr val="windowText" lastClr="000000"/>
+      </a:dk1>
+      <a:lt1>
+        <a:sysClr val="window" lastClr="FFFFFF"/>
+      </a:lt1>
+      <a:dk2>
+        <a:srgbClr val="44546A"/>
+      </a:dk2>
+      <a:lt2>
+        <a:srgbClr val="E7E6E6"/>
+      </a:lt2>
+      <a:accent1>
+        <a:srgbClr val="4472C4"/>
+      </a:accent1>
+      <a:accent2>
+        <a:srgbClr val="ED7D31"/>
+      </a:accent2>
+      <a:accent3>
+        <a:srgbClr val="A5A5A5"/>
+      </a:accent3>
+      <a:accent4>
+        <a:srgbClr val="FFC000"/>
+      </a:accent4>
+      <a:accent5>
+        <a:srgbClr val="5B9BD5"/>
+      </a:accent5>
+      <a:accent6>
+        <a:srgbClr val="70AD47"/>
+      </a:accent6>
+      <a:hlink>
+        <a:srgbClr val="0563C1"/>
+      </a:hlink>
+      <a:folHlink>
+        <a:srgbClr val="954F72"/>
+      </a:folHlink>
+    </a:clrScheme>
+    <a:fontScheme name="Office">
+      <a:majorFont>
+        <a:latin typeface="Calibri Light" panose="020F0302020204030204"/>
+        <a:ea typeface=""/>
+        <a:cs typeface=""/>
+        <a:font script="Jpan" typeface="游ゴシック Light"/>
+        <a:font script="Hang" typeface="맑은 고딕"/>
+        <a:font script="Hans" typeface="等线 Light"/>
+        <a:font script="Hant" typeface="新細明體"/>
+        <a:font script="Arab" typeface="Times New Roman"/>
+        <a:font script="Hebr" typeface="Times New Roman"/>
+        <a:font script="Thai" typeface="Angsana New"/>
+        <a:font script="Ethi" typeface="Nyala"/>
+        <a:font script="Beng" typeface="Vrinda"/>
+        <a:font script="Gujr" typeface="Shruti"/>
+        <a:font script="Khmr" typeface="MoolBoran"/>
+        <a:font script="Knda" typeface="Tunga"/>
+        <a:font script="Guru" typeface="Raavi"/>
+        <a:font script="Cans" typeface="Euphemia"/>
+        <a:font script="Cher" typeface="Plantagenet Cherokee"/>
+        <a:font script="Yiii" typeface="Microsoft Yi Baiti"/>
+        <a:font script="Tibt" typeface="Microsoft Himalaya"/>
+        <a:font script="Thaa" typeface="MV Boli"/>
+        <a:font script="Deva" typeface="Mangal"/>
+        <a:font script="Telu" typeface="Gautami"/>
+        <a:font script="Taml" typeface="Latha"/>
+        <a:font script="Syrc" typeface="Estrangelo Edessa"/>
+        <a:font script="Orya" typeface="Kalinga"/>
+        <a:font script="Mlym" typeface="Kartika"/>
+        <a:font script="Laoo" typeface="DokChampa"/>
+        <a:font script="Sinh" typeface="Iskoola Pota"/>
+        <a:font script="Mong" typeface="Mongolian Baiti"/>
+        <a:font script="Viet" typeface="Times New Roman"/>
+        <a:font script="Uigh" typeface="Microsoft Uighur"/>
+        <a:font script="Geor" typeface="Sylfaen"/>
+        <a:font script="Armn" typeface="Arial"/>
+        <a:font script="Bugi" typeface="Leelawadee UI"/>
+        <a:font script="Bopo" typeface="Microsoft JhengHei"/>
+        <a:font script="Java" typeface="Javanese Text"/>
+        <a:font script="Lisu" typeface="Segoe UI"/>
+        <a:font script="Mymr" typeface="Myanmar Text"/>
+        <a:font script="Nkoo" typeface="Ebrima"/>
+        <a:font script="Olck" typeface="Nirmala UI"/>
+        <a:font script="Osma" typeface="Ebrima"/>
+        <a:font script="Phag" typeface="Phagspa"/>
+        <a:font script="Syrn" typeface="Estrangelo Edessa"/>
+        <a:font script="Syrj" typeface="Estrangelo Edessa"/>
+        <a:font script="Syre" typeface="Estrangelo Edessa"/>
+        <a:font script="Sora" typeface="Nirmala UI"/>
+        <a:font script="Tale" typeface="Microsoft Tai Le"/>
+        <a:font script="Talu" typeface="Microsoft New Tai Lue"/>
+        <a:font script="Tfng" typeface="Ebrima"/>
+      </a:majorFont>
+      <a:minorFont>
+        <a:latin typeface="Calibri" panose="020F0502020204030204"/>
+        <a:ea typeface=""/>
+        <a:cs typeface=""/>
+        <a:font script="Jpan" typeface="游ゴシック"/>
+        <a:font script="Hang" typeface="맑은 고딕"/>
+        <a:font script="Hans" typeface="等线"/>
+        <a:font script="Hant" typeface="新細明體"/>
+        <a:font script="Arab" typeface="Arial"/>
+        <a:font script="Hebr" typeface="Arial"/>
+        <a:font script="Thai" typeface="Cordia New"/>
+        <a:font script="Ethi" typeface="Nyala"/>
+        <a:font script="Beng" typeface="Vrinda"/>
+        <a:font script="Gujr" typeface="Shruti"/>
+        <a:font script="Khmr" typeface="DaunPenh"/>
+        <a:font script="Knda" typeface="Tunga"/>
+        <a:font script="Guru" typeface="Raavi"/>
+        <a:font script="Cans" typeface="Euphemia"/>
+        <a:font script="Cher" typeface="Plantagenet Cherokee"/>
+        <a:font script="Yiii" typeface="Microsoft Yi Baiti"/>
+        <a:font script="Tibt" typeface="Microsoft Himalaya"/>
+        <a:font script="Thaa" typeface="MV Boli"/>
+        <a:font script="Deva" typeface="Mangal"/>
+        <a:font script="Telu" typeface="Gautami"/>
+        <a:font script="Taml" typeface="Latha"/>
+        <a:font script="Syrc" typeface="Estrangelo Edessa"/>
+        <a:font script="Orya" typeface="Kalinga"/>
+        <a:font script="Mlym" typeface="Kartika"/>
+        <a:font script="Laoo" typeface="DokChampa"/>
+        <a:font script="Sinh" typeface="Iskoola Pota"/>
+        <a:font script="Mong" typeface="Mongolian Baiti"/>
+        <a:font script="Viet" typeface="Arial"/>
+        <a:font script="Uigh" typeface="Microsoft Uighur"/>
+        <a:font script="Geor" typeface="Sylfaen"/>
+        <a:font script="Armn" typeface="Arial"/>
+        <a:font script="Bugi" typeface="Leelawadee UI"/>
+        <a:font script="Bopo" typeface="Microsoft JhengHei"/>
+        <a:font script="Java" typeface="Javanese Text"/>
+        <a:font script="Lisu" typeface="Segoe UI"/>
+        <a:font script="Mymr" typeface="Myanmar Text"/>
+        <a:font script="Nkoo" typeface="Ebrima"/>
+        <a:font script="Olck" typeface="Nirmala UI"/>
+        <a:font script="Osma" typeface="Ebrima"/>
+        <a:font script="Phag" typeface="Phagspa"/>
+        <a:font script="Syrn" typeface="Estrangelo Edessa"/>
+        <a:font script="Syrj" typeface="Estrangelo Edessa"/>
+        <a:font script="Syre" typeface="Estrangelo Edessa"/>
+        <a:font script="Sora" typeface="Nirmala UI"/>
+        <a:font script="Tale" typeface="Microsoft Tai Le"/>
+        <a:font script="Talu" typeface="Microsoft New Tai Lue"/>
+        <a:font script="Tfng" typeface="Ebrima"/>
+      </a:minorFont>
+    </a:fontScheme>
+    <a:fmtScheme name="Office">
+      <a:fillStyleLst>
+        <a:solidFill>
+          <a:schemeClr val="phClr"/>
+        </a:solidFill>
+        <a:gradFill rotWithShape="1">
+          <a:gsLst>
+            <a:gs pos="0">
+              <a:schemeClr val="phClr">
+                <a:lumMod val="110000"/>
+                <a:satMod val="105000"/>
+                <a:tint val="67000"/>
+              </a:schemeClr>
+            </a:gs>
+            <a:gs pos="50000">
+              <a:schemeClr val="phClr">
+                <a:lumMod val="105000"/>
+                <a:satMod val="103000"/>
+                <a:tint val="73000"/>
+              </a:schemeClr>
+            </a:gs>
+            <a:gs pos="100000">
+              <a:schemeClr val="phClr">
+                <a:lumMod val="105000"/>
+                <a:satMod val="109000"/>
+                <a:tint val="81000"/>
+              </a:schemeClr>
+            </a:gs>
+          </a:gsLst>
+          <a:lin ang="5400000" scaled="0"/>
+        </a:gradFill>
+        <a:gradFill rotWithShape="1">
+          <a:gsLst>
+            <a:gs pos="0">
+              <a:schemeClr val="phClr">
+                <a:satMod val="103000"/>
+                <a:lumMod val="102000"/>
+                <a:tint val="94000"/>
+              </a:schemeClr>
+            </a:gs>
+            <a:gs pos="50000">
+              <a:schemeClr val="phClr">
+                <a:satMod val="110000"/>
+                <a:lumMod val="100000"/>
+                <a:shade val="100000"/>
+              </a:schemeClr>
+            </a:gs>
+            <a:gs pos="100000">
+              <a:schemeClr val="phClr">
+                <a:lumMod val="99000"/>
+                <a:satMod val="120000"/>
+                <a:shade val="78000"/>
+              </a:schemeClr>
+            </a:gs>
+          </a:gsLst>
+          <a:lin ang="5400000" scaled="0"/>
+        </a:gradFill>
+      </a:fillStyleLst>
+      <a:lnStyleLst>
+        <a:ln w="6350" cap="flat" cmpd="sng" algn="ctr">
+          <a:solidFill>
+            <a:schemeClr val="phClr"/>
+          </a:solidFill>
+          <a:prstDash val="solid"/>
+          <a:miter lim="800000"/>
+        </a:ln>
+        <a:ln w="12700" cap="flat" cmpd="sng" algn="ctr">
+          <a:solidFill>
+            <a:schemeClr val="phClr"/>
+          </a:solidFill>
+          <a:prstDash val="solid"/>
+          <a:miter lim="800000"/>
+        </a:ln>
+        <a:ln w="19050" cap="flat" cmpd="sng" algn="ctr">
+          <a:solidFill>
+            <a:schemeClr val="phClr"/>
+          </a:solidFill>
+          <a:prstDash val="solid"/>
+          <a:miter lim="800000"/>
+        </a:ln>
+      </a:lnStyleLst>
+      <a:effectStyleLst>
+        <a:effectStyle>
+          <a:effectLst/>
+        </a:effectStyle>
+        <a:effectStyle>
+          <a:effectLst/>
+        </a:effectStyle>
+        <a:effectStyle>
+          <a:effectLst>
+            <a:outerShdw blurRad="57150" dist="19050" dir="5400000" algn="ctr" rotWithShape="0">
+              <a:srgbClr val="000000">
+                <a:alpha val="63000"/>
+              </a:srgbClr>
+            </a:outerShdw>
+          </a:effectLst>
+        </a:effectStyle>
+      </a:effectStyleLst>
+      <a:bgFillStyleLst>
+        <a:solidFill>
+          <a:schemeClr val="phClr"/>
+        </a:solidFill>
+        <a:solidFill>
+          <a:schemeClr val="phClr">
+            <a:tint val="95000"/>
+            <a:satMod val="170000"/>
+          </a:schemeClr>
+        </a:solidFill>
+        <a:gradFill rotWithShape="1">
+          <a:gsLst>
+            <a:gs pos="0">
+              <a:schemeClr val="phClr">
+                <a:tint val="93000"/>
+                <a:satMod val="150000"/>
+                <a:shade val="98000"/>
+                <a:lumMod val="102000"/>
+              </a:schemeClr>
+            </a:gs>
+            <a:gs pos="50000">
+              <a:schemeClr val="phClr">
+                <a:tint val="98000"/>
+                <a:satMod val="130000"/>
+                <a:shade val="90000"/>
+                <a:lumMod val="103000"/>
+              </a:schemeClr>
+            </a:gs>
+            <a:gs pos="100000">
+              <a:schemeClr val="phClr">
+                <a:shade val="63000"/>
+                <a:satMod val="120000"/>
+              </a:schemeClr>
+            </a:gs>
+          </a:gsLst>
+          <a:lin ang="5400000" scaled="0"/>
+        </a:gradFill>
+      </a:bgFillStyleLst>
+    </a:fmtScheme>
+  </a:themeElements>
+  <a:objectDefaults/>
+  <a:extraClrSchemeLst/>
+  <a:extLst>
+    <a:ext uri="{05A4C25C-085E-4340-85A3-A5531E510DB2}">
+      <thm15:themeFamily xmlns:thm15="http://schemas.microsoft.com/office/thememl/2012/main" name="Office Theme" id="{62F939B6-93AF-4DB8-9C6B-D6C7DFDC589F}" vid="{4A3C46E8-61CC-4603-A589-7422A47A8E4A}"/>
+    </a:ext>
+  </a:extLst>
+</a:theme>
 </file>
</xml_diff>